<commit_message>
Improve slides layout and add read-aloud speaker notes.
Larger body text and full-width images; strip session timing from projected slides; generate continuous presenter monologue for all 417 slides.

Co-authored-by: Cursor <cursoragent@cursor.com>
</commit_message>
<xml_diff>
--- a/slides/ModuleD_MultiBoard_EN.pptx
+++ b/slides/ModuleD_MultiBoard_EN.pptx
@@ -6,7 +6,7 @@
   </p:sldMasterIdLst>
   <p:sldIdLst>
     <p:sldId id="256" r:id="rId7"/>
-    <p:sldId id="257" r:id="rId8"/>
+    <p:sldId id="257" r:id="rId9"/>
     <p:sldId id="258" r:id="rId10"/>
     <p:sldId id="259" r:id="rId11"/>
     <p:sldId id="260" r:id="rId12"/>
@@ -540,7 +540,31 @@
           <a:lstStyle/>
           <a:p>
             <a:r>
-              <a:t>[EXT] 45 min</a:t>
+              <a:t>Welcome. In this module we will work through Module D — Multi-board &amp; Fleet Operations.</a:t>
+            </a:r>
+          </a:p>
+          <a:p/>
+          <a:p>
+            <a:r>
+              <a:t>Extension · Ch.13–14 · VM {{VM_IP}}</a:t>
+            </a:r>
+          </a:p>
+          <a:p/>
+          <a:p>
+            <a:r>
+              <a:t>The session alternates theory from the book with live exercises on the Stack4Things lab VM. Replace the placeholder IP with the address of the machine you are using.</a:t>
+            </a:r>
+          </a:p>
+          <a:p/>
+          <a:p>
+            <a:r>
+              <a:t>Extension · Ch.14 — Multi-board &amp; Fleet · prerequisite for Module G.</a:t>
+            </a:r>
+          </a:p>
+          <a:p/>
+          <a:p>
+            <a:r>
+              <a:t>When you're ready, advance to the first section.</a:t>
             </a:r>
           </a:p>
         </p:txBody>
@@ -610,7 +634,31 @@
           <a:lstStyle/>
           <a:p>
             <a:r>
-              <a:t>[EXT] 45 min</a:t>
+              <a:t>In this slide we cover Fleet operations beyond inject (Ch.14 §14.2). This material is covered in Ch.14 §14.2 · supported fleet operations · fig:fleetinjPop.</a:t>
+            </a:r>
+          </a:p>
+          <a:p/>
+          <a:p>
+            <a:r>
+              <a:t>First, Fleet-level async Start launches background plugins on all members simultaneously. Next, Fleet update pushes revised plugin source to every attached board in one operation.</a:t>
+            </a:r>
+          </a:p>
+          <a:p/>
+          <a:p>
+            <a:r>
+              <a:t>By contrast, Fleet remove detaches plugin from all members — boards remain Active in Horizon. We should also consider that regarding fleet health, absence or failure of one member can break fleet-level application logic.</a:t>
+            </a:r>
+          </a:p>
+          <a:p/>
+          <a:p>
+            <a:r>
+              <a:t>Another key point is that regarding rest api mirrors horizon, fleet CRUD and bulk plugin operations via Conductor. Furthermore, Lab focuses on sync HelloName fleet inject — async fleet Start is production pattern for Ch.15.</a:t>
+            </a:r>
+          </a:p>
+          <a:p/>
+          <a:p>
+            <a:r>
+              <a:t>I'll pause here for questions, then we'll continue.</a:t>
             </a:r>
           </a:p>
         </p:txBody>
@@ -680,7 +728,7 @@
           <a:lstStyle/>
           <a:p>
             <a:r>
-              <a:t>[EXT] 45 min</a:t>
+              <a:t>Please look at the diagram on screen: Multi-board fleet topology. Describe the main boxes and arrows. Relate each element to a Docker service or API you have already seen. In particular, note the following: Three LR instances → one IoTronic Conductor → fleet-level plugin inject. Take a few seconds to orient before we continue.</a:t>
             </a:r>
           </a:p>
         </p:txBody>
@@ -750,7 +798,31 @@
           <a:lstStyle/>
           <a:p>
             <a:r>
-              <a:t>[EXT] 45 min</a:t>
+              <a:t>On this slide, Module D — learning objectives.</a:t>
+            </a:r>
+          </a:p>
+          <a:p/>
+          <a:p>
+            <a:r>
+              <a:t>First, Start lightning-rod-2 and lightning-rod-3 on host ports 1475 and 1476. Next, Register board-alpha, board-beta, board-gamma — all Active in Horizon.</a:t>
+            </a:r>
+          </a:p>
+          <a:p/>
+          <a:p>
+            <a:r>
+              <a:t>By contrast, Create a fleet containing all three boards. We should also consider that Fleet inject HelloName sync plugin; verify Plugin Call on each board.</a:t>
+            </a:r>
+          </a:p>
+          <a:p/>
+          <a:p>
+            <a:r>
+              <a:t>Another key point is that Pass validate-lab-multiboard.sh — prerequisite for Module G Federated Learning.</a:t>
+            </a:r>
+          </a:p>
+          <a:p/>
+          <a:p>
+            <a:r>
+              <a:t>If these objectives are clear, we can proceed.</a:t>
             </a:r>
           </a:p>
         </p:txBody>
@@ -820,7 +892,37 @@
           <a:lstStyle/>
           <a:p>
             <a:r>
-              <a:t>[EXT] 45 min</a:t>
+              <a:t>In this demonstration, What this module proves — demo goals.</a:t>
+            </a:r>
+          </a:p>
+          <a:p/>
+          <a:p>
+            <a:r>
+              <a:t>First, Same IoTronic Conductor orchestrates multiple edge agents concurrently. Next, Fleet inject deploys identical plugin logic to all members in one Horizon action.</a:t>
+            </a:r>
+          </a:p>
+          <a:p/>
+          <a:p>
+            <a:r>
+              <a:t>By contrast, Each board maintains independent LR runtime — fleet is logical grouping only. We should also consider that regarding prerequisite satisfied for module g, 3 Active clients on separate boards for FL.</a:t>
+            </a:r>
+          </a:p>
+          <a:p/>
+          <a:p>
+            <a:r>
+              <a:t>Another key point is that regarding mirrors production rollout, test plugin on one board, then fleet inject for deployment. Furthermore, Students can articulate difference between board inject and fleet inject.</a:t>
+            </a:r>
+          </a:p>
+          <a:p/>
+          <a:p>
+            <a:r>
+              <a:t>Check that your screen matches what we showed before moving on.</a:t>
+            </a:r>
+          </a:p>
+          <a:p/>
+          <a:p>
+            <a:r>
+              <a:t>Session timing — Module D — 45-minute timeline:</a:t>
             </a:r>
           </a:p>
         </p:txBody>
@@ -890,7 +992,13 @@
           <a:lstStyle/>
           <a:p>
             <a:r>
-              <a:t>[EXT] 6 min</a:t>
+              <a:t>We now begin a new section: Lab: start extra Lightning-Rod instances. Docker Compose lab overlay. In the next slides, listen for whether we are in theory mode or hands-on mode, and open your terminal when the slides turn to lab work.</a:t>
+            </a:r>
+          </a:p>
+          <a:p/>
+          <a:p>
+            <a:r>
+              <a:t>Instructor timing (title): Hands-on — start extra Lightning-Rod instances</a:t>
             </a:r>
           </a:p>
         </p:txBody>
@@ -960,7 +1068,37 @@
           <a:lstStyle/>
           <a:p>
             <a:r>
-              <a:t>[EXT] 45 min</a:t>
+              <a:t>Now we move to the hands-on part: Start LR-2 and LR-3 containers. Open your lab VM and follow along.</a:t>
+            </a:r>
+          </a:p>
+          <a:p/>
+          <a:p>
+            <a:r>
+              <a:t>Please run the following command on your VM: cd training/repos/ch13. Wait until you see a sensible result before continuing. Please run the following command on your VM: docker compose -f docker-compose.yml \. Wait until you see a sensible result before continuing.</a:t>
+            </a:r>
+          </a:p>
+          <a:p/>
+          <a:p>
+            <a:r>
+              <a:t>By contrast, -f ../../patches/docker-compose.lab.yml up -d lightning-rod-2 lightning-rod-3. Please run the following command on your VM: training/experiments/multiboard/check-endpoints.sh. Wait until you see a sensible result before continuing.</a:t>
+            </a:r>
+          </a:p>
+          <a:p/>
+          <a:p>
+            <a:r>
+              <a:t>Another key point is that regarding expected, HTTP 200 on {{VM_IP}}:1475 and {{VM_IP}}:1476.</a:t>
+            </a:r>
+          </a:p>
+          <a:p/>
+          <a:p>
+            <a:r>
+              <a:t>Raise your hand if you're stuck — we'll wait until most of you are done.</a:t>
+            </a:r>
+          </a:p>
+          <a:p/>
+          <a:p>
+            <a:r>
+              <a:t>Instructor timing (title): Step 1 — Start LR-2 and LR-3 containers</a:t>
             </a:r>
           </a:p>
         </p:txBody>
@@ -1030,7 +1168,31 @@
           <a:lstStyle/>
           <a:p>
             <a:r>
-              <a:t>[EXT] 45 min</a:t>
+              <a:t>In this slide we cover Lab compose port mapping (Ch.13 patch). This material is covered in training/patches/docker-compose.lab.yml · ch13 repo.</a:t>
+            </a:r>
+          </a:p>
+          <a:p/>
+          <a:p>
+            <a:r>
+              <a:t>First, Docker-compose.lab.yml adds lightning-rod-2, then host :1475, lightning-rod-3, then :1476. Next, regarding default lightning-rod (instance 1) remains on, 1474 from Module A.</a:t>
+            </a:r>
+          </a:p>
+          <a:p/>
+          <a:p>
+            <a:r>
+              <a:t>By contrast, All three share iotronic-network — WAMP crossbar reachable as wss://crossbar:8181. We should also consider that Check-endpoints.sh verifies UI reachability before board registration begins.</a:t>
+            </a:r>
+          </a:p>
+          <a:p/>
+          <a:p>
+            <a:r>
+              <a:t>Another key point is that regarding container names, lightning-rod, lightning-rod-2, lightning-rod-3 — distinct hostnames. Furthermore, regarding if port conflict, ensure no other service bound to 1475/1476 on lab VM.</a:t>
+            </a:r>
+          </a:p>
+          <a:p/>
+          <a:p>
+            <a:r>
+              <a:t>I'll pause here for questions, then we'll continue.</a:t>
             </a:r>
           </a:p>
         </p:txBody>
@@ -1100,7 +1262,13 @@
           <a:lstStyle/>
           <a:p>
             <a:r>
-              <a:t>[EXT] 45 min</a:t>
+              <a:t>We now begin a new section: Lab: register three boards in Horizon. Create Board × 3. In the next slides, listen for whether we are in theory mode or hands-on mode, and open your terminal when the slides turn to lab work.</a:t>
+            </a:r>
+          </a:p>
+          <a:p/>
+          <a:p>
+            <a:r>
+              <a:t>Instructor timing (title): Hands-on — register three boards in Horizon</a:t>
             </a:r>
           </a:p>
         </p:txBody>
@@ -1170,7 +1338,7 @@
           <a:lstStyle/>
           <a:p>
             <a:r>
-              <a:t>[EXT] 6 min</a:t>
+              <a:t>Please look at the screenshot on screen: Horizon IoT — Boards dashboard (create 3 boards). Walk the class through what they see in the interface. Connect each panel and button to a component we already deployed in the stack. In particular, note the following: http://{{VM_IP}}/horizon/iot/ → Create Board × 3 · login admin / s4t. Take a few seconds to orient before we continue.</a:t>
             </a:r>
           </a:p>
         </p:txBody>
@@ -1240,7 +1408,37 @@
           <a:lstStyle/>
           <a:p>
             <a:r>
-              <a:t>[EXT] 45 min</a:t>
+              <a:t>Now we move to the hands-on part: Create three boards in Horizon. Open your lab VM and follow along.</a:t>
+            </a:r>
+          </a:p>
+          <a:p/>
+          <a:p>
+            <a:r>
+              <a:t>First, regarding open http, //{{VM_IP}}/horizon/iot/ — login admin / s4t. Next, regarding create board, board-alpha, then copy registration code to notepad.</a:t>
+            </a:r>
+          </a:p>
+          <a:p/>
+          <a:p>
+            <a:r>
+              <a:t>By contrast, regarding create board, board-beta, then copy registration code. We should also consider that regarding create board, board-gamma, then copy registration code.</a:t>
+            </a:r>
+          </a:p>
+          <a:p/>
+          <a:p>
+            <a:r>
+              <a:t>Another key point is that Do NOT reuse codes — each board gets a unique one-time registration token.</a:t>
+            </a:r>
+          </a:p>
+          <a:p/>
+          <a:p>
+            <a:r>
+              <a:t>Raise your hand if you're stuck — we'll wait until most of you are done.</a:t>
+            </a:r>
+          </a:p>
+          <a:p/>
+          <a:p>
+            <a:r>
+              <a:t>Instructor timing (title): Step 2 — Create three boards in Horizon</a:t>
             </a:r>
           </a:p>
         </p:txBody>
@@ -1310,7 +1508,7 @@
           <a:lstStyle/>
           <a:p>
             <a:r>
-              <a:t>[EXT] 45 min</a:t>
+              <a:t>We now begin a new section: Why multiple boards?. Fleet theory before scaling the lab. In the next slides, listen for whether we are in theory mode or hands-on mode, and open your terminal when the slides turn to lab work.</a:t>
             </a:r>
           </a:p>
         </p:txBody>
@@ -1380,7 +1578,7 @@
           <a:lstStyle/>
           <a:p>
             <a:r>
-              <a:t>[EXT] 45 min</a:t>
+              <a:t>Please look at the screenshot on screen: Book figure — Create Board form (Ch.13). Walk the class through what they see in the interface. Connect each panel and button to a component we already deployed in the stack. In particular, note the following: Reference UI fields: name, description, registration code display. Take a few seconds to orient before we continue.</a:t>
             </a:r>
           </a:p>
         </p:txBody>
@@ -1450,7 +1648,13 @@
           <a:lstStyle/>
           <a:p>
             <a:r>
-              <a:t>[EXT] 45 min</a:t>
+              <a:t>We now begin a new section: Lab: configure each Lightning-Rod. Registration code + WAMP URL. In the next slides, listen for whether we are in theory mode or hands-on mode, and open your terminal when the slides turn to lab work.</a:t>
+            </a:r>
+          </a:p>
+          <a:p/>
+          <a:p>
+            <a:r>
+              <a:t>Instructor timing (title): Hands-on — configure each Lightning-Rod</a:t>
             </a:r>
           </a:p>
         </p:txBody>
@@ -1520,7 +1724,7 @@
           <a:lstStyle/>
           <a:p>
             <a:r>
-              <a:t>[EXT] 45 min</a:t>
+              <a:t>Please look at the screenshot on screen: LR instance 1 — Configuration (board-alpha). Walk the class through what they see in the interface. Connect each panel and button to a component we already deployed in the stack. In particular, note the following: http://{{VM_IP}}:1474/config — board-alpha · me / arancino. Take a few seconds to orient before we continue.</a:t>
             </a:r>
           </a:p>
         </p:txBody>
@@ -1590,7 +1794,7 @@
           <a:lstStyle/>
           <a:p>
             <a:r>
-              <a:t>[EXT] 6 min</a:t>
+              <a:t>Please look at the screenshot on screen: LR instance 2 — home dashboard. Walk the class through what they see in the interface. Connect each panel and button to a component we already deployed in the stack. In particular, note the following: http://{{VM_IP}}:1475 — board-beta will register here. Take a few seconds to orient before we continue.</a:t>
             </a:r>
           </a:p>
         </p:txBody>
@@ -1660,7 +1864,31 @@
           <a:lstStyle/>
           <a:p>
             <a:r>
-              <a:t>[EXT] 45 min</a:t>
+              <a:t>Now we move to the hands-on part: Configure Lightning-Rod instance 1 (alpha). Open your lab VM and follow along.</a:t>
+            </a:r>
+          </a:p>
+          <a:p/>
+          <a:p>
+            <a:r>
+              <a:t>First, regarding open http, //{{VM_IP}}:1474/config — login me / arancino. Next, Paste board-alpha registration code.</a:t>
+            </a:r>
+          </a:p>
+          <a:p/>
+          <a:p>
+            <a:r>
+              <a:t>By contrast, regarding wamp url, wss://crossbar:8181 · Save. We should also consider that Verify board-alpha shows Active in Horizon before proceeding.</a:t>
+            </a:r>
+          </a:p>
+          <a:p/>
+          <a:p>
+            <a:r>
+              <a:t>Raise your hand if you're stuck — we'll wait until most of you are done.</a:t>
+            </a:r>
+          </a:p>
+          <a:p/>
+          <a:p>
+            <a:r>
+              <a:t>Instructor timing (title): Step 3 — Configure Lightning-Rod instance 1 (alpha)</a:t>
             </a:r>
           </a:p>
         </p:txBody>
@@ -1730,7 +1958,7 @@
           <a:lstStyle/>
           <a:p>
             <a:r>
-              <a:t>[EXT] 6 min</a:t>
+              <a:t>Please look at the screenshot on screen: LR instance 2 — Configuration (board-beta). Walk the class through what they see in the interface. Connect each panel and button to a component we already deployed in the stack. In particular, note the following: http://{{VM_IP}}:1475/config — board-beta registration. Take a few seconds to orient before we continue.</a:t>
             </a:r>
           </a:p>
         </p:txBody>
@@ -1800,7 +2028,31 @@
           <a:lstStyle/>
           <a:p>
             <a:r>
-              <a:t>[EXT] 45 min</a:t>
+              <a:t>Now we move to the hands-on part: Configure Lightning-Rod instance 2 (beta). Open your lab VM and follow along.</a:t>
+            </a:r>
+          </a:p>
+          <a:p/>
+          <a:p>
+            <a:r>
+              <a:t>First, regarding open http, //{{VM_IP}}:1475/config — login me / arancino. Next, regarding paste board-beta registration code · wamp, wss://crossbar:8181 · Save.</a:t>
+            </a:r>
+          </a:p>
+          <a:p/>
+          <a:p>
+            <a:r>
+              <a:t>By contrast, Wait for Active status in Horizon.</a:t>
+            </a:r>
+          </a:p>
+          <a:p/>
+          <a:p>
+            <a:r>
+              <a:t>Raise your hand if you're stuck — we'll wait until most of you are done.</a:t>
+            </a:r>
+          </a:p>
+          <a:p/>
+          <a:p>
+            <a:r>
+              <a:t>Instructor timing (title): Step 4 — Configure Lightning-Rod instance 2 (beta)</a:t>
             </a:r>
           </a:p>
         </p:txBody>
@@ -1870,7 +2122,7 @@
           <a:lstStyle/>
           <a:p>
             <a:r>
-              <a:t>[EXT] 45 min</a:t>
+              <a:t>Please look at the screenshot on screen: LR instance 3 — home dashboard. Walk the class through what they see in the interface. Connect each panel and button to a component we already deployed in the stack. In particular, note the following: http://{{VM_IP}}:1476 — board-gamma will register here. Take a few seconds to orient before we continue.</a:t>
             </a:r>
           </a:p>
         </p:txBody>
@@ -1940,7 +2192,7 @@
           <a:lstStyle/>
           <a:p>
             <a:r>
-              <a:t>[EXT] 6 min</a:t>
+              <a:t>Please look at the screenshot on screen: LR instance 3 — Configuration (board-gamma). Walk the class through what they see in the interface. Connect each panel and button to a component we already deployed in the stack. In particular, note the following: http://{{VM_IP}}:1476/config — board-gamma registration. Take a few seconds to orient before we continue.</a:t>
             </a:r>
           </a:p>
         </p:txBody>
@@ -2010,7 +2262,31 @@
           <a:lstStyle/>
           <a:p>
             <a:r>
-              <a:t>[EXT] 45 min</a:t>
+              <a:t>Now we move to the hands-on part: Configure Lightning-Rod instance 3 (gamma). Open your lab VM and follow along.</a:t>
+            </a:r>
+          </a:p>
+          <a:p/>
+          <a:p>
+            <a:r>
+              <a:t>First, regarding open http, //{{VM_IP}}:1476/config — login me / arancino. Next, regarding paste board-gamma registration code · wamp, wss://crossbar:8181 · Save.</a:t>
+            </a:r>
+          </a:p>
+          <a:p/>
+          <a:p>
+            <a:r>
+              <a:t>By contrast, All three boards MUST show Active in Horizon before fleet inject.</a:t>
+            </a:r>
+          </a:p>
+          <a:p/>
+          <a:p>
+            <a:r>
+              <a:t>Raise your hand if you're stuck — we'll wait until most of you are done.</a:t>
+            </a:r>
+          </a:p>
+          <a:p/>
+          <a:p>
+            <a:r>
+              <a:t>Instructor timing (title): Step 5 — Configure Lightning-Rod instance 3 (gamma)</a:t>
             </a:r>
           </a:p>
         </p:txBody>
@@ -2080,7 +2356,31 @@
           <a:lstStyle/>
           <a:p>
             <a:r>
-              <a:t>[EXT] 45 min</a:t>
+              <a:t>In this slide we cover Scaling from one board to a fleet (Ch.13–14). This material is covered in Ch.13 multi-board note · Ch.14 fleet abstract.</a:t>
+            </a:r>
+          </a:p>
+          <a:p/>
+          <a:p>
+            <a:r>
+              <a:t>First, Real S4T deployments manage hundreds of heterogeneous boards across sites. Next, Each board = one Lightning-Rod instance with unique IoTronic registration code.</a:t>
+            </a:r>
+          </a:p>
+          <a:p/>
+          <a:p>
+            <a:r>
+              <a:t>By contrast, Lab simulates 3 boards via lightning-rod, lightning-rod-2, lightning-rod-3 containers. We should also consider that Same cloud IoTronic Conductor manages all boards under one Keystone tenant.</a:t>
+            </a:r>
+          </a:p>
+          <a:p/>
+          <a:p>
+            <a:r>
+              <a:t>Another key point is that Multi-board topology mirrors TOO(L)SMART multi-station urban deployments (Ch.15). Furthermore, Book repo ch13 documents docker-compose scaling pattern used in this module.</a:t>
+            </a:r>
+          </a:p>
+          <a:p/>
+          <a:p>
+            <a:r>
+              <a:t>I'll pause here for questions, then we'll continue.</a:t>
             </a:r>
           </a:p>
         </p:txBody>
@@ -2150,7 +2450,31 @@
           <a:lstStyle/>
           <a:p>
             <a:r>
-              <a:t>[EXT] 45 min</a:t>
+              <a:t>In this slide we cover Troubleshooting multi-board registration. This material is covered in Ch.13 troubleshooting · IoTronic REST API.</a:t>
+            </a:r>
+          </a:p>
+          <a:p/>
+          <a:p>
+            <a:r>
+              <a:t>First, regarding board stuck in registering, check LR logs — docker logs lightning-rod-2. Next, regarding wrong code on wrong lr, board shows Error — remove and re-create board in Horizon.</a:t>
+            </a:r>
+          </a:p>
+          <a:p/>
+          <a:p>
+            <a:r>
+              <a:t>By contrast, regarding wamp connection refused, verify crossbar container healthy in docker compose ps. We should also consider that regarding duplicate registration, each code valid for one LR instance only.</a:t>
+            </a:r>
+          </a:p>
+          <a:p/>
+          <a:p>
+            <a:r>
+              <a:t>Another key point is that regarding api check, curl -s http://{{VM_IP}}:8812/v1/boards/ | python3 -m json.tool. Furthermore, All three status fields must read Active before continuing to fleet creation.</a:t>
+            </a:r>
+          </a:p>
+          <a:p/>
+          <a:p>
+            <a:r>
+              <a:t>I'll pause here for questions, then we'll continue.</a:t>
             </a:r>
           </a:p>
         </p:txBody>
@@ -2220,7 +2544,13 @@
           <a:lstStyle/>
           <a:p>
             <a:r>
-              <a:t>[EXT] 45 min</a:t>
+              <a:t>We now begin a new section: Lab: create fleet and inject HelloName. Fleet-level plugin deploy. In the next slides, listen for whether we are in theory mode or hands-on mode, and open your terminal when the slides turn to lab work.</a:t>
+            </a:r>
+          </a:p>
+          <a:p/>
+          <a:p>
+            <a:r>
+              <a:t>Instructor timing (title): Hands-on — create fleet and inject HelloName</a:t>
             </a:r>
           </a:p>
         </p:txBody>
@@ -2290,7 +2620,7 @@
           <a:lstStyle/>
           <a:p>
             <a:r>
-              <a:t>[EXT] 45 min</a:t>
+              <a:t>Please look at the sequence diagram on screen: UML sequence — Fleet plugin inject (Module D). Trace the diagram from left to right. Name each actor, the protocol used, and the message that crosses the cloud–edge boundary. In particular, note the following: Create fleet → inject HelloName on board-alpha, beta, gamma. Take a few seconds to orient before we continue.</a:t>
             </a:r>
           </a:p>
         </p:txBody>
@@ -2360,7 +2690,7 @@
           <a:lstStyle/>
           <a:p>
             <a:r>
-              <a:t>[EXT] 6 min</a:t>
+              <a:t>Please look at the screenshot on screen: Horizon IoT — Fleets panel. Walk the class through what they see in the interface. Connect each panel and button to a component we already deployed in the stack. In particular, note the following: http://{{VM_IP}}/horizon/iot/fleets/ — Create Fleet. Take a few seconds to orient before we continue.</a:t>
             </a:r>
           </a:p>
         </p:txBody>
@@ -2430,7 +2760,31 @@
           <a:lstStyle/>
           <a:p>
             <a:r>
-              <a:t>[EXT] 6 min</a:t>
+              <a:t>Now we move to the hands-on part: Create fleet and add all Active boards. Open your lab VM and follow along.</a:t>
+            </a:r>
+          </a:p>
+          <a:p/>
+          <a:p>
+            <a:r>
+              <a:t>First, regarding http, //{{VM_IP}}/horizon/iot/fleets/, then Create Fleet. Next, regarding name, lab-fleet-3 · add board-alpha, board-beta, board-gamma.</a:t>
+            </a:r>
+          </a:p>
+          <a:p/>
+          <a:p>
+            <a:r>
+              <a:t>By contrast, Save — verify all three members listed in fleet detail view.</a:t>
+            </a:r>
+          </a:p>
+          <a:p/>
+          <a:p>
+            <a:r>
+              <a:t>Raise your hand if you're stuck — we'll wait until most of you are done.</a:t>
+            </a:r>
+          </a:p>
+          <a:p/>
+          <a:p>
+            <a:r>
+              <a:t>Instructor timing (title): Step 6 — Create fleet and add all Active boards</a:t>
             </a:r>
           </a:p>
         </p:txBody>
@@ -2500,7 +2854,31 @@
           <a:lstStyle/>
           <a:p>
             <a:r>
-              <a:t>[EXT] 45 min</a:t>
+              <a:t>Now we move to the hands-on part: Fleet inject HelloName plugin. Open your lab VM and follow along.</a:t>
+            </a:r>
+          </a:p>
+          <a:p/>
+          <a:p>
+            <a:r>
+              <a:t>First, Fleet, then Plugins tab, then Inject, then select HelloName (from Module B). Next, Confirm inject succeeds on all three members.</a:t>
+            </a:r>
+          </a:p>
+          <a:p/>
+          <a:p>
+            <a:r>
+              <a:t>By contrast, regarding per board, plugins, then HelloName, then Plugin Call, then {"name": "fleet-demo"}. We should also consider that regarding verify json result returned on each of, 1474, :1475, :1476 boards.</a:t>
+            </a:r>
+          </a:p>
+          <a:p/>
+          <a:p>
+            <a:r>
+              <a:t>Raise your hand if you're stuck — we'll wait until most of you are done.</a:t>
+            </a:r>
+          </a:p>
+          <a:p/>
+          <a:p>
+            <a:r>
+              <a:t>Instructor timing (title): Step 7 — Fleet inject HelloName plugin</a:t>
             </a:r>
           </a:p>
         </p:txBody>
@@ -2570,7 +2948,31 @@
           <a:lstStyle/>
           <a:p>
             <a:r>
-              <a:t>[EXT] 45 min</a:t>
+              <a:t>In this slide we cover Fleet inject vs individual inject — when to use each. This material is covered in Ch.14 §14.2 · bulk plugin deployment.</a:t>
+            </a:r>
+          </a:p>
+          <a:p/>
+          <a:p>
+            <a:r>
+              <a:t>First, regarding development/debug, individual board inject — isolate failures quickly. Next, regarding production rollout, fleet inject — consistent version across all edge nodes.</a:t>
+            </a:r>
+          </a:p>
+          <a:p/>
+          <a:p>
+            <a:r>
+              <a:t>By contrast, regarding heterogeneous fleets, filter members by tag/metadata before inject (production feature). We should also consider that regarding helloname sync demo, fleet inject saves time; Plugin Call proves per-board execution.</a:t>
+            </a:r>
+          </a:p>
+          <a:p/>
+          <a:p>
+            <a:r>
+              <a:t>Another key point is that regarding module g fl, per-board async inject with different CSV — not fleet inject pattern. Furthermore, Book Ch.14 fleet panel screenshots match Horizon workflow shown in hands-on steps.</a:t>
+            </a:r>
+          </a:p>
+          <a:p/>
+          <a:p>
+            <a:r>
+              <a:t>I'll pause here for questions, then we'll continue.</a:t>
             </a:r>
           </a:p>
         </p:txBody>
@@ -2640,7 +3042,7 @@
           <a:lstStyle/>
           <a:p>
             <a:r>
-              <a:t>[EXT] 6 min</a:t>
+              <a:t>We now begin a new section: Validate &amp; wrap-up. Confirm lab state for Module G. In the next slides, listen for whether we are in theory mode or hands-on mode, and open your terminal when the slides turn to lab work.</a:t>
             </a:r>
           </a:p>
         </p:txBody>
@@ -2710,7 +3112,125 @@
           <a:lstStyle/>
           <a:p>
             <a:r>
-              <a:t>[EXT] 45 min</a:t>
+              <a:t>Now we move to the hands-on part: Validate multi-board lab state. Open your lab VM and follow along.</a:t>
+            </a:r>
+          </a:p>
+          <a:p/>
+          <a:p>
+            <a:r>
+              <a:t>Please run the following command on your VM: cd training &amp;&amp; ./validate-lab-multiboard.sh. Wait until you see a sensible result before continuing. Please run the following command on your VM: curl -s http://{{VM_IP}}:8812/v1/boards/ | python3 -m json.tool. Wait until you see a sensible result before continuing.</a:t>
+            </a:r>
+          </a:p>
+          <a:p/>
+          <a:p>
+            <a:r>
+              <a:t>By contrast, regarding expected, 3 boards, all status Active, fleet lab-fleet-3 exists.</a:t>
+            </a:r>
+          </a:p>
+          <a:p/>
+          <a:p>
+            <a:r>
+              <a:t>Raise your hand if you're stuck — we'll wait until most of you are done.</a:t>
+            </a:r>
+          </a:p>
+          <a:p/>
+          <a:p>
+            <a:r>
+              <a:t>Instructor timing (title): Step 8 — Validate multi-board lab state</a:t>
+            </a:r>
+          </a:p>
+        </p:txBody>
+      </p:sp>
+      <p:sp>
+        <p:nvSpPr>
+          <p:cNvPr id="4" name="Slide Number Placeholder 3"/>
+          <p:cNvSpPr>
+            <a:spLocks noGrp="1"/>
+          </p:cNvSpPr>
+          <p:nvPr>
+            <p:ph type="sldNum" idx="5" sz="quarter"/>
+          </p:nvPr>
+        </p:nvSpPr>
+        <p:spPr/>
+      </p:sp>
+    </p:spTree>
+  </p:cSld>
+  <p:clrMapOvr>
+    <a:masterClrMapping/>
+  </p:clrMapOvr>
+</p:notes>
+</file>
+
+<file path=ppt/notesSlides/notesSlide39.xml><?xml version="1.0" encoding="utf-8"?>
+<p:notes xmlns:a="http://schemas.openxmlformats.org/drawingml/2006/main" xmlns:p="http://schemas.openxmlformats.org/presentationml/2006/main" xmlns:r="http://schemas.openxmlformats.org/officeDocument/2006/relationships">
+  <p:cSld>
+    <p:spTree>
+      <p:nvGrpSpPr>
+        <p:cNvPr id="1" name=""/>
+        <p:cNvGrpSpPr/>
+        <p:nvPr/>
+      </p:nvGrpSpPr>
+      <p:grpSpPr>
+        <a:xfrm>
+          <a:off x="0" y="0"/>
+          <a:ext cx="0" cy="0"/>
+          <a:chOff x="0" y="0"/>
+          <a:chExt cx="0" cy="0"/>
+        </a:xfrm>
+      </p:grpSpPr>
+      <p:sp>
+        <p:nvSpPr>
+          <p:cNvPr id="2" name="Slide Image Placeholder 1"/>
+          <p:cNvSpPr>
+            <a:spLocks noGrp="1"/>
+          </p:cNvSpPr>
+          <p:nvPr>
+            <p:ph type="sldImg" idx="2"/>
+          </p:nvPr>
+        </p:nvSpPr>
+        <p:spPr/>
+      </p:sp>
+      <p:sp>
+        <p:nvSpPr>
+          <p:cNvPr id="3" name="Notes Placeholder 2"/>
+          <p:cNvSpPr>
+            <a:spLocks noGrp="1"/>
+          </p:cNvSpPr>
+          <p:nvPr>
+            <p:ph type="body" idx="3" sz="quarter"/>
+          </p:nvPr>
+        </p:nvSpPr>
+        <p:spPr/>
+        <p:txBody>
+          <a:bodyPr/>
+          <a:lstStyle/>
+          <a:p>
+            <a:r>
+              <a:t>On this slide, Module D checklist.</a:t>
+            </a:r>
+          </a:p>
+          <a:p/>
+          <a:p>
+            <a:r>
+              <a:t>First, □ Three boards Active in Horizon (board-alpha, board-beta, board-gamma). Next, regarding □ three lr uis reachable, {{VM_IP}}:1474, :1475, :1476.</a:t>
+            </a:r>
+          </a:p>
+          <a:p/>
+          <a:p>
+            <a:r>
+              <a:t>By contrast, □ Fleet created with HelloName injected on all members. We should also consider that □ validate-lab-multiboard.sh passes.</a:t>
+            </a:r>
+          </a:p>
+          <a:p/>
+          <a:p>
+            <a:r>
+              <a:t>Another key point is that Prerequisite satisfied, then proceed to Module G (Federated Learning) or Module F (WSTUN).</a:t>
+            </a:r>
+          </a:p>
+          <a:p/>
+          <a:p>
+            <a:r>
+              <a:t>If these objectives are clear, we can proceed.</a:t>
             </a:r>
           </a:p>
         </p:txBody>
@@ -2780,7 +3300,31 @@
           <a:lstStyle/>
           <a:p>
             <a:r>
-              <a:t>[EXT] 45 min</a:t>
+              <a:t>In this slide we cover Lightning-Rod instance isolation (Ch.13). This material is covered in Ch.13 § Lightning-Rod configuration · fig:chap13:lr-conf.</a:t>
+            </a:r>
+          </a:p>
+          <a:p/>
+          <a:p>
+            <a:r>
+              <a:t>First, regarding each lr container binds a distinct host port (, 1474, :1475, :1476) for its Web UI. Next, regarding wamp connection shares crossbar, 8181 — IoTronic distinguishes boards by registration.</a:t>
+            </a:r>
+          </a:p>
+          <a:p/>
+          <a:p>
+            <a:r>
+              <a:t>By contrast, Board metadata (name, UUID, status) stored in IoTronic MariaDB — not in LR container. We should also consider that Plugin inject targets a specific board UUID or an entire fleet collection.</a:t>
+            </a:r>
+          </a:p>
+          <a:p/>
+          <a:p>
+            <a:r>
+              <a:t>Another key point is that regarding credentials per lr dashboard, me / arancino — same pattern on all three instances. Furthermore, Active state requires successful WAMP handshake + heartbeat to Conductor.</a:t>
+            </a:r>
+          </a:p>
+          <a:p/>
+          <a:p>
+            <a:r>
+              <a:t>I'll pause here for questions, then we'll continue.</a:t>
             </a:r>
           </a:p>
         </p:txBody>
@@ -2850,7 +3394,31 @@
           <a:lstStyle/>
           <a:p>
             <a:r>
-              <a:t>[EXT] 45 min</a:t>
+              <a:t>In this slide we cover Board registration workflow recap (Ch.13). This material is covered in Ch.13 § board onboarding · listing create_board.</a:t>
+            </a:r>
+          </a:p>
+          <a:p/>
+          <a:p>
+            <a:r>
+              <a:t>First, Horizon IoT, then Create Board, then copy one-time registration code. Next, regarding lr configuration page, paste code, set WAMP URL wss://crossbar:8181, save.</a:t>
+            </a:r>
+          </a:p>
+          <a:p/>
+          <a:p>
+            <a:r>
+              <a:t>By contrast, regarding board transitions, created, then Registering, then Active (or Error if misconfigured). We should also consider that regarding three boards in this module, board-alpha, board-beta, board-gamma.</a:t>
+            </a:r>
+          </a:p>
+          <a:p/>
+          <a:p>
+            <a:r>
+              <a:t>Another key point is that Each board gets independent plugin namespace — inject does not cross boards unless fleet. Furthermore, regarding rest api mirror, GET /v1/boards/ lists all registered boards with status field.</a:t>
+            </a:r>
+          </a:p>
+          <a:p/>
+          <a:p>
+            <a:r>
+              <a:t>I'll pause here for questions, then we'll continue.</a:t>
             </a:r>
           </a:p>
         </p:txBody>
@@ -2920,7 +3488,31 @@
           <a:lstStyle/>
           <a:p>
             <a:r>
-              <a:t>[EXT] 45 min</a:t>
+              <a:t>In this slide we cover Fleet abstraction in depth (Ch.14 §14.2). This material is covered in Ch.14 §14.2 · Stack4Things fleet management.</a:t>
+            </a:r>
+          </a:p>
+          <a:p/>
+          <a:p>
+            <a:r>
+              <a:t>First, Fleet ≠ trivial label — semantically meaningful collection of IoT devices. Next, Tenant-aware grouping under OpenStack Keystone multi-tenancy model.</a:t>
+            </a:r>
+          </a:p>
+          <a:p/>
+          <a:p>
+            <a:r>
+              <a:t>By contrast, regarding members act in unison, one fleet-level inject reaches ALL boards in the fleet. We should also consider that Absence or failure of one member can affect fleet-level application behaviour.</a:t>
+            </a:r>
+          </a:p>
+          <a:p/>
+          <a:p>
+            <a:r>
+              <a:t>Another key point is that regarding fleet metadata editable, name, description, member add/remove without re-registering boards. Furthermore, regarding book figures, fig:fleetpanel, fig:fleetpanelCreation, fig:fleetinjPop.</a:t>
+            </a:r>
+          </a:p>
+          <a:p/>
+          <a:p>
+            <a:r>
+              <a:t>I'll pause here for questions, then we'll continue.</a:t>
             </a:r>
           </a:p>
         </p:txBody>
@@ -2990,7 +3582,31 @@
           <a:lstStyle/>
           <a:p>
             <a:r>
-              <a:t>[EXT] 45 min</a:t>
+              <a:t>In this slide we cover Fleet vs individual board operations (Ch.14). This material is covered in Ch.14 bulk plugin deployment · fig:fleetinjPop.</a:t>
+            </a:r>
+          </a:p>
+          <a:p/>
+          <a:p>
+            <a:r>
+              <a:t>First, regarding individual inject, fine-grained control, debugging one misbehaving board. Next, regarding fleet inject, operational efficiency at scale — one UI action, N boards updated.</a:t>
+            </a:r>
+          </a:p>
+          <a:p/>
+          <a:p>
+            <a:r>
+              <a:t>By contrast, Same Worker Python code runs on each LR independently after fleet inject. We should also consider that Plugin Call (sync) still per-board unless custom fleet orchestration API used.</a:t>
+            </a:r>
+          </a:p>
+          <a:p/>
+          <a:p>
+            <a:r>
+              <a:t>Another key point is that Fleet delete removes grouping only — boards remain registered and Active. Furthermore, regarding production pattern, dev/test on single board, then promote inject to fleet for rollout.</a:t>
+            </a:r>
+          </a:p>
+          <a:p/>
+          <a:p>
+            <a:r>
+              <a:t>I'll pause here for questions, then we'll continue.</a:t>
             </a:r>
           </a:p>
         </p:txBody>
@@ -3060,7 +3676,31 @@
           <a:lstStyle/>
           <a:p>
             <a:r>
-              <a:t>[EXT] 45 min</a:t>
+              <a:t>In this slide we cover Horizon fleet UI workflow (Ch.14). This material is covered in Ch.14 § Stack4Things fleets · Horizon IoT dashboard.</a:t>
+            </a:r>
+          </a:p>
+          <a:p/>
+          <a:p>
+            <a:r>
+              <a:t>First, regarding fleets panel, http://{{VM_IP}}/horizon/iot/fleets/ — create, filter, edit, delete. Next, regarding create fleet, name + description, then add member boards from Active board list.</a:t>
+            </a:r>
+          </a:p>
+          <a:p/>
+          <a:p>
+            <a:r>
+              <a:t>By contrast, regarding fleet detail → plugins tab, inject / update / remove on ALL fleet members at once. We should also consider that Boards panel remains for device-level troubleshooting and individual actions.</a:t>
+            </a:r>
+          </a:p>
+          <a:p/>
+          <a:p>
+            <a:r>
+              <a:t>Another key point is that regarding horizon login, admin / s4t — same tenant sees all boards and fleets. Furthermore, Screenshots in deck captured from live lab — regenerate via capture_dashboards.py.</a:t>
+            </a:r>
+          </a:p>
+          <a:p/>
+          <a:p>
+            <a:r>
+              <a:t>I'll pause here for questions, then we'll continue.</a:t>
             </a:r>
           </a:p>
         </p:txBody>
@@ -3130,7 +3770,31 @@
           <a:lstStyle/>
           <a:p>
             <a:r>
-              <a:t>[EXT] 45 min</a:t>
+              <a:t>In this slide we cover Plugin inject on fleet — execution model (Ch.14). This material is covered in Ch.14 §14.1 plugin lifecycle · fleet inject listing.</a:t>
+            </a:r>
+          </a:p>
+          <a:p/>
+          <a:p>
+            <a:r>
+              <a:t>First, IoTronic sends inject command to each fleet member's Lightning-Rod concurrently. Next, Each LR Plugin Manager loads Worker class independently — no shared process.</a:t>
+            </a:r>
+          </a:p>
+          <a:p/>
+          <a:p>
+            <a:r>
+              <a:t>By contrast, regarding sync plugin (helloname), after fleet inject, Plugin Call is still one board at a time. We should also consider that regarding async plugin, start on fleet would launch background loop on every member simultaneously.</a:t>
+            </a:r>
+          </a:p>
+          <a:p/>
+          <a:p>
+            <a:r>
+              <a:t>Another key point is that regarding fleet inject failure on one member, check that board's LR logs before retrying fleet action. Furthermore, Module G (FL) uses per-board async inject — fleet inject not used for Flower clients.</a:t>
+            </a:r>
+          </a:p>
+          <a:p/>
+          <a:p>
+            <a:r>
+              <a:t>I'll pause here for questions, then we'll continue.</a:t>
             </a:r>
           </a:p>
         </p:txBody>
@@ -6306,7 +6970,7 @@
           <a:lstStyle/>
           <a:p>
             <a:pPr>
-              <a:defRPr sz="3800" b="1">
+              <a:defRPr sz="4000" b="1">
                 <a:solidFill>
                   <a:srgbClr val="FFFFFF"/>
                 </a:solidFill>
@@ -6345,7 +7009,7 @@
               <a:spcAft>
                 <a:spcPts val="400"/>
               </a:spcAft>
-              <a:defRPr sz="2000" b="0">
+              <a:defRPr sz="2200" b="0">
                 <a:solidFill>
                   <a:srgbClr val="B2EBF2"/>
                 </a:solidFill>
@@ -6353,7 +7017,7 @@
               </a:defRPr>
             </a:pPr>
             <a:r>
-              <a:t>Extension · +45–60 min · Ch.13–14 · VM {{VM_IP}}</a:t>
+              <a:t>Extension · Ch.13–14 · VM {{VM_IP}}</a:t>
             </a:r>
           </a:p>
         </p:txBody>
@@ -6582,7 +7246,7 @@
           <a:lstStyle/>
           <a:p>
             <a:pPr algn="r">
-              <a:defRPr sz="1000" b="0">
+              <a:defRPr sz="1100" b="0">
                 <a:solidFill>
                   <a:srgbClr val="78909C"/>
                 </a:solidFill>
@@ -6618,7 +7282,7 @@
           <a:lstStyle/>
           <a:p>
             <a:pPr>
-              <a:defRPr sz="2400" b="1">
+              <a:defRPr sz="2600" b="1">
                 <a:solidFill>
                   <a:srgbClr val="0D2B45"/>
                 </a:solidFill>
@@ -6640,7 +7304,7 @@
         <p:spPr>
           <a:xfrm>
             <a:off x="502920" y="1554480"/>
-            <a:ext cx="11155680" cy="2651759"/>
+            <a:ext cx="11155680" cy="4800600"/>
           </a:xfrm>
           <a:prstGeom prst="roundRect">
             <a:avLst/>
@@ -6685,7 +7349,7 @@
         <p:spPr>
           <a:xfrm>
             <a:off x="777240" y="1673352"/>
-            <a:ext cx="10424160" cy="2468879"/>
+            <a:ext cx="10424160" cy="4572000"/>
           </a:xfrm>
           <a:prstGeom prst="rect">
             <a:avLst/>
@@ -6705,7 +7369,7 @@
               <a:spcAft>
                 <a:spcPts val="500"/>
               </a:spcAft>
-              <a:defRPr sz="1500" b="0">
+              <a:defRPr sz="1600" b="0">
                 <a:solidFill>
                   <a:srgbClr val="37474F"/>
                 </a:solidFill>
@@ -6724,7 +7388,7 @@
               <a:spcAft>
                 <a:spcPts val="500"/>
               </a:spcAft>
-              <a:defRPr sz="1500" b="0">
+              <a:defRPr sz="1600" b="0">
                 <a:solidFill>
                   <a:srgbClr val="37474F"/>
                 </a:solidFill>
@@ -6743,7 +7407,7 @@
               <a:spcAft>
                 <a:spcPts val="500"/>
               </a:spcAft>
-              <a:defRPr sz="1500" b="0">
+              <a:defRPr sz="1600" b="0">
                 <a:solidFill>
                   <a:srgbClr val="37474F"/>
                 </a:solidFill>
@@ -6762,7 +7426,7 @@
               <a:spcAft>
                 <a:spcPts val="500"/>
               </a:spcAft>
-              <a:defRPr sz="1500" b="0">
+              <a:defRPr sz="1600" b="0">
                 <a:solidFill>
                   <a:srgbClr val="37474F"/>
                 </a:solidFill>
@@ -6781,7 +7445,7 @@
               <a:spcAft>
                 <a:spcPts val="500"/>
               </a:spcAft>
-              <a:defRPr sz="1500" b="0">
+              <a:defRPr sz="1600" b="0">
                 <a:solidFill>
                   <a:srgbClr val="37474F"/>
                 </a:solidFill>
@@ -6800,7 +7464,7 @@
               <a:spcAft>
                 <a:spcPts val="500"/>
               </a:spcAft>
-              <a:defRPr sz="1500" b="0">
+              <a:defRPr sz="1600" b="0">
                 <a:solidFill>
                   <a:srgbClr val="37474F"/>
                 </a:solidFill>
@@ -7005,7 +7669,7 @@
         </p:nvSpPr>
         <p:spPr>
           <a:xfrm>
-            <a:off x="594360" y="438912"/>
+            <a:off x="594360" y="347472"/>
             <a:ext cx="10972800" cy="868680"/>
           </a:xfrm>
           <a:prstGeom prst="rect">
@@ -7041,8 +7705,8 @@
         </p:nvSpPr>
         <p:spPr>
           <a:xfrm>
-            <a:off x="2542260" y="1426464"/>
-            <a:ext cx="7107173" cy="4123944"/>
+            <a:off x="1120368" y="1298448"/>
+            <a:ext cx="9950958" cy="5733288"/>
           </a:xfrm>
           <a:prstGeom prst="roundRect">
             <a:avLst/>
@@ -7094,8 +7758,8 @@
         </p:blipFill>
         <p:spPr>
           <a:xfrm>
-            <a:off x="2615412" y="1499616"/>
-            <a:ext cx="6960869" cy="3977639"/>
+            <a:off x="1175232" y="1353312"/>
+            <a:ext cx="9841230" cy="5623560"/>
           </a:xfrm>
           <a:prstGeom prst="rect">
             <a:avLst/>
@@ -7110,7 +7774,7 @@
         </p:nvSpPr>
         <p:spPr>
           <a:xfrm>
-            <a:off x="594360" y="5687568"/>
+            <a:off x="594360" y="7168896"/>
             <a:ext cx="10972800" cy="411480"/>
           </a:xfrm>
           <a:prstGeom prst="rect">
@@ -7125,7 +7789,7 @@
           <a:lstStyle/>
           <a:p>
             <a:pPr>
-              <a:defRPr sz="1100" b="0">
+              <a:defRPr sz="1200" b="0">
                 <a:solidFill>
                   <a:srgbClr val="37474F"/>
                 </a:solidFill>
@@ -7345,7 +8009,7 @@
           <a:lstStyle/>
           <a:p>
             <a:pPr>
-              <a:defRPr sz="2800" b="1">
+              <a:defRPr sz="3000" b="1">
                 <a:solidFill>
                   <a:srgbClr val="0D2B45"/>
                 </a:solidFill>
@@ -7367,7 +8031,7 @@
         <p:spPr>
           <a:xfrm>
             <a:off x="502920" y="1344168"/>
-            <a:ext cx="11155680" cy="2331720"/>
+            <a:ext cx="11155680" cy="5010912"/>
           </a:xfrm>
           <a:prstGeom prst="roundRect">
             <a:avLst/>
@@ -7412,7 +8076,7 @@
         <p:spPr>
           <a:xfrm>
             <a:off x="777240" y="1463040"/>
-            <a:ext cx="10424160" cy="2148840"/>
+            <a:ext cx="10424160" cy="4782312"/>
           </a:xfrm>
           <a:prstGeom prst="rect">
             <a:avLst/>
@@ -7432,7 +8096,7 @@
               <a:spcAft>
                 <a:spcPts val="800"/>
               </a:spcAft>
-              <a:defRPr sz="1700" b="0">
+              <a:defRPr sz="1900" b="0">
                 <a:solidFill>
                   <a:srgbClr val="37474F"/>
                 </a:solidFill>
@@ -7451,7 +8115,7 @@
               <a:spcAft>
                 <a:spcPts val="800"/>
               </a:spcAft>
-              <a:defRPr sz="1700" b="0">
+              <a:defRPr sz="1900" b="0">
                 <a:solidFill>
                   <a:srgbClr val="37474F"/>
                 </a:solidFill>
@@ -7470,7 +8134,7 @@
               <a:spcAft>
                 <a:spcPts val="800"/>
               </a:spcAft>
-              <a:defRPr sz="1700" b="0">
+              <a:defRPr sz="1900" b="0">
                 <a:solidFill>
                   <a:srgbClr val="37474F"/>
                 </a:solidFill>
@@ -7489,7 +8153,7 @@
               <a:spcAft>
                 <a:spcPts val="800"/>
               </a:spcAft>
-              <a:defRPr sz="1700" b="0">
+              <a:defRPr sz="1900" b="0">
                 <a:solidFill>
                   <a:srgbClr val="37474F"/>
                 </a:solidFill>
@@ -7508,7 +8172,7 @@
               <a:spcAft>
                 <a:spcPts val="800"/>
               </a:spcAft>
-              <a:defRPr sz="1700" b="0">
+              <a:defRPr sz="1900" b="0">
                 <a:solidFill>
                   <a:srgbClr val="37474F"/>
                 </a:solidFill>
@@ -7745,7 +8409,7 @@
           <a:lstStyle/>
           <a:p>
             <a:pPr>
-              <a:defRPr sz="2400" b="1">
+              <a:defRPr sz="2600" b="1">
                 <a:solidFill>
                   <a:srgbClr val="0D2B45"/>
                 </a:solidFill>
@@ -7767,7 +8431,7 @@
         <p:spPr>
           <a:xfrm>
             <a:off x="502920" y="1554480"/>
-            <a:ext cx="11155680" cy="2651759"/>
+            <a:ext cx="11155680" cy="4800600"/>
           </a:xfrm>
           <a:prstGeom prst="roundRect">
             <a:avLst/>
@@ -7812,7 +8476,7 @@
         <p:spPr>
           <a:xfrm>
             <a:off x="777240" y="1673352"/>
-            <a:ext cx="10424160" cy="2468879"/>
+            <a:ext cx="10424160" cy="4572000"/>
           </a:xfrm>
           <a:prstGeom prst="rect">
             <a:avLst/>
@@ -7832,7 +8496,7 @@
               <a:spcAft>
                 <a:spcPts val="500"/>
               </a:spcAft>
-              <a:defRPr sz="1500" b="0">
+              <a:defRPr sz="1600" b="0">
                 <a:solidFill>
                   <a:srgbClr val="37474F"/>
                 </a:solidFill>
@@ -7851,7 +8515,7 @@
               <a:spcAft>
                 <a:spcPts val="500"/>
               </a:spcAft>
-              <a:defRPr sz="1500" b="0">
+              <a:defRPr sz="1600" b="0">
                 <a:solidFill>
                   <a:srgbClr val="37474F"/>
                 </a:solidFill>
@@ -7870,7 +8534,7 @@
               <a:spcAft>
                 <a:spcPts val="500"/>
               </a:spcAft>
-              <a:defRPr sz="1500" b="0">
+              <a:defRPr sz="1600" b="0">
                 <a:solidFill>
                   <a:srgbClr val="37474F"/>
                 </a:solidFill>
@@ -7889,7 +8553,7 @@
               <a:spcAft>
                 <a:spcPts val="500"/>
               </a:spcAft>
-              <a:defRPr sz="1500" b="0">
+              <a:defRPr sz="1600" b="0">
                 <a:solidFill>
                   <a:srgbClr val="37474F"/>
                 </a:solidFill>
@@ -7908,7 +8572,7 @@
               <a:spcAft>
                 <a:spcPts val="500"/>
               </a:spcAft>
-              <a:defRPr sz="1500" b="0">
+              <a:defRPr sz="1600" b="0">
                 <a:solidFill>
                   <a:srgbClr val="37474F"/>
                 </a:solidFill>
@@ -7927,7 +8591,7 @@
               <a:spcAft>
                 <a:spcPts val="500"/>
               </a:spcAft>
-              <a:defRPr sz="1500" b="0">
+              <a:defRPr sz="1600" b="0">
                 <a:solidFill>
                   <a:srgbClr val="37474F"/>
                 </a:solidFill>
@@ -8147,7 +8811,7 @@
           <a:lstStyle/>
           <a:p>
             <a:pPr algn="ctr">
-              <a:defRPr sz="3600" b="1">
+              <a:defRPr sz="3800" b="1">
                 <a:solidFill>
                   <a:srgbClr val="FFFFFF"/>
                 </a:solidFill>
@@ -8183,7 +8847,7 @@
           <a:lstStyle/>
           <a:p>
             <a:pPr algn="ctr">
-              <a:defRPr sz="2000" b="0">
+              <a:defRPr sz="2200" b="0">
                 <a:solidFill>
                   <a:srgbClr val="B2EBF2"/>
                 </a:solidFill>
@@ -8288,7 +8952,7 @@
           <a:lstStyle/>
           <a:p>
             <a:pPr>
-              <a:defRPr sz="2800" b="1">
+              <a:defRPr sz="3000" b="1">
                 <a:solidFill>
                   <a:srgbClr val="0D2B45"/>
                 </a:solidFill>
@@ -8310,7 +8974,7 @@
         <p:spPr>
           <a:xfrm>
             <a:off x="502920" y="1344168"/>
-            <a:ext cx="11155680" cy="2331720"/>
+            <a:ext cx="11155680" cy="5010912"/>
           </a:xfrm>
           <a:prstGeom prst="roundRect">
             <a:avLst/>
@@ -8355,7 +9019,7 @@
         <p:spPr>
           <a:xfrm>
             <a:off x="777240" y="1463040"/>
-            <a:ext cx="10424160" cy="2148840"/>
+            <a:ext cx="10424160" cy="4782312"/>
           </a:xfrm>
           <a:prstGeom prst="rect">
             <a:avLst/>
@@ -8375,7 +9039,7 @@
               <a:spcAft>
                 <a:spcPts val="800"/>
               </a:spcAft>
-              <a:defRPr sz="1300" b="0">
+              <a:defRPr sz="1400" b="0">
                 <a:solidFill>
                   <a:srgbClr val="0D2B45"/>
                 </a:solidFill>
@@ -8394,7 +9058,7 @@
               <a:spcAft>
                 <a:spcPts val="800"/>
               </a:spcAft>
-              <a:defRPr sz="1300" b="0">
+              <a:defRPr sz="1400" b="0">
                 <a:solidFill>
                   <a:srgbClr val="0D2B45"/>
                 </a:solidFill>
@@ -8413,7 +9077,7 @@
               <a:spcAft>
                 <a:spcPts val="800"/>
               </a:spcAft>
-              <a:defRPr sz="1700" b="0">
+              <a:defRPr sz="1900" b="0">
                 <a:solidFill>
                   <a:srgbClr val="37474F"/>
                 </a:solidFill>
@@ -8432,7 +9096,7 @@
               <a:spcAft>
                 <a:spcPts val="800"/>
               </a:spcAft>
-              <a:defRPr sz="1300" b="0">
+              <a:defRPr sz="1400" b="0">
                 <a:solidFill>
                   <a:srgbClr val="0D2B45"/>
                 </a:solidFill>
@@ -8451,7 +9115,7 @@
               <a:spcAft>
                 <a:spcPts val="800"/>
               </a:spcAft>
-              <a:defRPr sz="1700" b="0">
+              <a:defRPr sz="1900" b="0">
                 <a:solidFill>
                   <a:srgbClr val="37474F"/>
                 </a:solidFill>
@@ -8688,7 +9352,7 @@
           <a:lstStyle/>
           <a:p>
             <a:pPr algn="r">
-              <a:defRPr sz="1000" b="0">
+              <a:defRPr sz="1100" b="0">
                 <a:solidFill>
                   <a:srgbClr val="78909C"/>
                 </a:solidFill>
@@ -8724,7 +9388,7 @@
           <a:lstStyle/>
           <a:p>
             <a:pPr>
-              <a:defRPr sz="2400" b="1">
+              <a:defRPr sz="2600" b="1">
                 <a:solidFill>
                   <a:srgbClr val="0D2B45"/>
                 </a:solidFill>
@@ -8746,7 +9410,7 @@
         <p:spPr>
           <a:xfrm>
             <a:off x="502920" y="1554480"/>
-            <a:ext cx="11155680" cy="2651759"/>
+            <a:ext cx="11155680" cy="4800600"/>
           </a:xfrm>
           <a:prstGeom prst="roundRect">
             <a:avLst/>
@@ -8791,7 +9455,7 @@
         <p:spPr>
           <a:xfrm>
             <a:off x="777240" y="1673352"/>
-            <a:ext cx="10424160" cy="2468879"/>
+            <a:ext cx="10424160" cy="4572000"/>
           </a:xfrm>
           <a:prstGeom prst="rect">
             <a:avLst/>
@@ -8811,7 +9475,7 @@
               <a:spcAft>
                 <a:spcPts val="500"/>
               </a:spcAft>
-              <a:defRPr sz="1500" b="0">
+              <a:defRPr sz="1600" b="0">
                 <a:solidFill>
                   <a:srgbClr val="37474F"/>
                 </a:solidFill>
@@ -8830,7 +9494,7 @@
               <a:spcAft>
                 <a:spcPts val="500"/>
               </a:spcAft>
-              <a:defRPr sz="1500" b="0">
+              <a:defRPr sz="1600" b="0">
                 <a:solidFill>
                   <a:srgbClr val="37474F"/>
                 </a:solidFill>
@@ -8849,7 +9513,7 @@
               <a:spcAft>
                 <a:spcPts val="500"/>
               </a:spcAft>
-              <a:defRPr sz="1500" b="0">
+              <a:defRPr sz="1600" b="0">
                 <a:solidFill>
                   <a:srgbClr val="37474F"/>
                 </a:solidFill>
@@ -8868,7 +9532,7 @@
               <a:spcAft>
                 <a:spcPts val="500"/>
               </a:spcAft>
-              <a:defRPr sz="1500" b="0">
+              <a:defRPr sz="1600" b="0">
                 <a:solidFill>
                   <a:srgbClr val="37474F"/>
                 </a:solidFill>
@@ -8887,7 +9551,7 @@
               <a:spcAft>
                 <a:spcPts val="500"/>
               </a:spcAft>
-              <a:defRPr sz="1500" b="0">
+              <a:defRPr sz="1600" b="0">
                 <a:solidFill>
                   <a:srgbClr val="37474F"/>
                 </a:solidFill>
@@ -8906,7 +9570,7 @@
               <a:spcAft>
                 <a:spcPts val="500"/>
               </a:spcAft>
-              <a:defRPr sz="1500" b="0">
+              <a:defRPr sz="1600" b="0">
                 <a:solidFill>
                   <a:srgbClr val="37474F"/>
                 </a:solidFill>
@@ -9126,7 +9790,7 @@
           <a:lstStyle/>
           <a:p>
             <a:pPr algn="ctr">
-              <a:defRPr sz="3600" b="1">
+              <a:defRPr sz="3800" b="1">
                 <a:solidFill>
                   <a:srgbClr val="FFFFFF"/>
                 </a:solidFill>
@@ -9162,7 +9826,7 @@
           <a:lstStyle/>
           <a:p>
             <a:pPr algn="ctr">
-              <a:defRPr sz="2000" b="0">
+              <a:defRPr sz="2200" b="0">
                 <a:solidFill>
                   <a:srgbClr val="B2EBF2"/>
                 </a:solidFill>
@@ -9252,7 +9916,7 @@
         </p:nvSpPr>
         <p:spPr>
           <a:xfrm>
-            <a:off x="594360" y="438912"/>
+            <a:off x="594360" y="347472"/>
             <a:ext cx="10972800" cy="868680"/>
           </a:xfrm>
           <a:prstGeom prst="rect">
@@ -9288,8 +9952,8 @@
         </p:nvSpPr>
         <p:spPr>
           <a:xfrm>
-            <a:off x="2928975" y="1426464"/>
-            <a:ext cx="6333744" cy="4123944"/>
+            <a:off x="1667103" y="1298448"/>
+            <a:ext cx="8857488" cy="5733288"/>
           </a:xfrm>
           <a:prstGeom prst="roundRect">
             <a:avLst/>
@@ -9341,8 +10005,8 @@
         </p:blipFill>
         <p:spPr>
           <a:xfrm>
-            <a:off x="3002127" y="1499616"/>
-            <a:ext cx="6187440" cy="3977639"/>
+            <a:off x="1721967" y="1353312"/>
+            <a:ext cx="8747760" cy="5623560"/>
           </a:xfrm>
           <a:prstGeom prst="rect">
             <a:avLst/>
@@ -9357,7 +10021,7 @@
         </p:nvSpPr>
         <p:spPr>
           <a:xfrm>
-            <a:off x="594360" y="5687568"/>
+            <a:off x="594360" y="7168896"/>
             <a:ext cx="10972800" cy="411480"/>
           </a:xfrm>
           <a:prstGeom prst="rect">
@@ -9372,7 +10036,7 @@
           <a:lstStyle/>
           <a:p>
             <a:pPr>
-              <a:defRPr sz="1100" b="0">
+              <a:defRPr sz="1200" b="0">
                 <a:solidFill>
                   <a:srgbClr val="37474F"/>
                 </a:solidFill>
@@ -9592,7 +10256,7 @@
           <a:lstStyle/>
           <a:p>
             <a:pPr>
-              <a:defRPr sz="2800" b="1">
+              <a:defRPr sz="3000" b="1">
                 <a:solidFill>
                   <a:srgbClr val="0D2B45"/>
                 </a:solidFill>
@@ -9614,7 +10278,7 @@
         <p:spPr>
           <a:xfrm>
             <a:off x="502920" y="1344168"/>
-            <a:ext cx="11155680" cy="2331720"/>
+            <a:ext cx="11155680" cy="5010912"/>
           </a:xfrm>
           <a:prstGeom prst="roundRect">
             <a:avLst/>
@@ -9659,7 +10323,7 @@
         <p:spPr>
           <a:xfrm>
             <a:off x="777240" y="1463040"/>
-            <a:ext cx="10424160" cy="2148840"/>
+            <a:ext cx="10424160" cy="4782312"/>
           </a:xfrm>
           <a:prstGeom prst="rect">
             <a:avLst/>
@@ -9679,7 +10343,7 @@
               <a:spcAft>
                 <a:spcPts val="800"/>
               </a:spcAft>
-              <a:defRPr sz="1700" b="0">
+              <a:defRPr sz="1900" b="0">
                 <a:solidFill>
                   <a:srgbClr val="37474F"/>
                 </a:solidFill>
@@ -9698,7 +10362,7 @@
               <a:spcAft>
                 <a:spcPts val="800"/>
               </a:spcAft>
-              <a:defRPr sz="1700" b="0">
+              <a:defRPr sz="1900" b="0">
                 <a:solidFill>
                   <a:srgbClr val="37474F"/>
                 </a:solidFill>
@@ -9717,7 +10381,7 @@
               <a:spcAft>
                 <a:spcPts val="800"/>
               </a:spcAft>
-              <a:defRPr sz="1700" b="0">
+              <a:defRPr sz="1900" b="0">
                 <a:solidFill>
                   <a:srgbClr val="37474F"/>
                 </a:solidFill>
@@ -9736,7 +10400,7 @@
               <a:spcAft>
                 <a:spcPts val="800"/>
               </a:spcAft>
-              <a:defRPr sz="1700" b="0">
+              <a:defRPr sz="1900" b="0">
                 <a:solidFill>
                   <a:srgbClr val="37474F"/>
                 </a:solidFill>
@@ -9755,7 +10419,7 @@
               <a:spcAft>
                 <a:spcPts val="800"/>
               </a:spcAft>
-              <a:defRPr sz="1700" b="0">
+              <a:defRPr sz="1900" b="0">
                 <a:solidFill>
                   <a:srgbClr val="37474F"/>
                 </a:solidFill>
@@ -9939,7 +10603,7 @@
           <a:lstStyle/>
           <a:p>
             <a:pPr algn="ctr">
-              <a:defRPr sz="3600" b="1">
+              <a:defRPr sz="3800" b="1">
                 <a:solidFill>
                   <a:srgbClr val="FFFFFF"/>
                 </a:solidFill>
@@ -9975,7 +10639,7 @@
           <a:lstStyle/>
           <a:p>
             <a:pPr algn="ctr">
-              <a:defRPr sz="2000" b="0">
+              <a:defRPr sz="2200" b="0">
                 <a:solidFill>
                   <a:srgbClr val="B2EBF2"/>
                 </a:solidFill>
@@ -10065,7 +10729,7 @@
         </p:nvSpPr>
         <p:spPr>
           <a:xfrm>
-            <a:off x="594360" y="438912"/>
+            <a:off x="594360" y="347472"/>
             <a:ext cx="10972800" cy="868680"/>
           </a:xfrm>
           <a:prstGeom prst="rect">
@@ -10101,8 +10765,8 @@
         </p:nvSpPr>
         <p:spPr>
           <a:xfrm>
-            <a:off x="1084935" y="1426464"/>
-            <a:ext cx="10021824" cy="3990972"/>
+            <a:off x="280263" y="1298448"/>
+            <a:ext cx="11631167" cy="4595174"/>
           </a:xfrm>
           <a:prstGeom prst="roundRect">
             <a:avLst/>
@@ -10154,8 +10818,8 @@
         </p:blipFill>
         <p:spPr>
           <a:xfrm>
-            <a:off x="1158087" y="1499616"/>
-            <a:ext cx="9875520" cy="3844668"/>
+            <a:off x="335127" y="1353312"/>
+            <a:ext cx="11521440" cy="4485446"/>
           </a:xfrm>
           <a:prstGeom prst="rect">
             <a:avLst/>
@@ -10170,7 +10834,7 @@
         </p:nvSpPr>
         <p:spPr>
           <a:xfrm>
-            <a:off x="594360" y="5554596"/>
+            <a:off x="594360" y="6030782"/>
             <a:ext cx="10972800" cy="411480"/>
           </a:xfrm>
           <a:prstGeom prst="rect">
@@ -10185,7 +10849,7 @@
           <a:lstStyle/>
           <a:p>
             <a:pPr>
-              <a:defRPr sz="1100" b="0">
+              <a:defRPr sz="1200" b="0">
                 <a:solidFill>
                   <a:srgbClr val="37474F"/>
                 </a:solidFill>
@@ -10405,7 +11069,7 @@
           <a:lstStyle/>
           <a:p>
             <a:pPr algn="ctr">
-              <a:defRPr sz="3600" b="1">
+              <a:defRPr sz="3800" b="1">
                 <a:solidFill>
                   <a:srgbClr val="FFFFFF"/>
                 </a:solidFill>
@@ -10441,7 +11105,7 @@
           <a:lstStyle/>
           <a:p>
             <a:pPr algn="ctr">
-              <a:defRPr sz="2000" b="0">
+              <a:defRPr sz="2200" b="0">
                 <a:solidFill>
                   <a:srgbClr val="B2EBF2"/>
                 </a:solidFill>
@@ -10531,7 +11195,7 @@
         </p:nvSpPr>
         <p:spPr>
           <a:xfrm>
-            <a:off x="594360" y="438912"/>
+            <a:off x="594360" y="347472"/>
             <a:ext cx="10972800" cy="868680"/>
           </a:xfrm>
           <a:prstGeom prst="rect">
@@ -10567,8 +11231,8 @@
         </p:nvSpPr>
         <p:spPr>
           <a:xfrm>
-            <a:off x="2928975" y="1426464"/>
-            <a:ext cx="6333744" cy="4123944"/>
+            <a:off x="1667103" y="1298448"/>
+            <a:ext cx="8857488" cy="5733288"/>
           </a:xfrm>
           <a:prstGeom prst="roundRect">
             <a:avLst/>
@@ -10620,8 +11284,8 @@
         </p:blipFill>
         <p:spPr>
           <a:xfrm>
-            <a:off x="3002127" y="1499616"/>
-            <a:ext cx="6187440" cy="3977639"/>
+            <a:off x="1721967" y="1353312"/>
+            <a:ext cx="8747760" cy="5623560"/>
           </a:xfrm>
           <a:prstGeom prst="rect">
             <a:avLst/>
@@ -10636,7 +11300,7 @@
         </p:nvSpPr>
         <p:spPr>
           <a:xfrm>
-            <a:off x="594360" y="5687568"/>
+            <a:off x="594360" y="7168896"/>
             <a:ext cx="10972800" cy="411480"/>
           </a:xfrm>
           <a:prstGeom prst="rect">
@@ -10651,7 +11315,7 @@
           <a:lstStyle/>
           <a:p>
             <a:pPr>
-              <a:defRPr sz="1100" b="0">
+              <a:defRPr sz="1200" b="0">
                 <a:solidFill>
                   <a:srgbClr val="37474F"/>
                 </a:solidFill>
@@ -10856,7 +11520,7 @@
         </p:nvSpPr>
         <p:spPr>
           <a:xfrm>
-            <a:off x="594360" y="438912"/>
+            <a:off x="594360" y="347472"/>
             <a:ext cx="10972800" cy="868680"/>
           </a:xfrm>
           <a:prstGeom prst="rect">
@@ -10892,8 +11556,8 @@
         </p:nvSpPr>
         <p:spPr>
           <a:xfrm>
-            <a:off x="2928975" y="1426464"/>
-            <a:ext cx="6333744" cy="4123944"/>
+            <a:off x="1667103" y="1298448"/>
+            <a:ext cx="8857488" cy="5733288"/>
           </a:xfrm>
           <a:prstGeom prst="roundRect">
             <a:avLst/>
@@ -10945,8 +11609,8 @@
         </p:blipFill>
         <p:spPr>
           <a:xfrm>
-            <a:off x="3002127" y="1499616"/>
-            <a:ext cx="6187440" cy="3977639"/>
+            <a:off x="1721967" y="1353312"/>
+            <a:ext cx="8747760" cy="5623560"/>
           </a:xfrm>
           <a:prstGeom prst="rect">
             <a:avLst/>
@@ -10961,7 +11625,7 @@
         </p:nvSpPr>
         <p:spPr>
           <a:xfrm>
-            <a:off x="594360" y="5687568"/>
+            <a:off x="594360" y="7168896"/>
             <a:ext cx="10972800" cy="411480"/>
           </a:xfrm>
           <a:prstGeom prst="rect">
@@ -10976,7 +11640,7 @@
           <a:lstStyle/>
           <a:p>
             <a:pPr>
-              <a:defRPr sz="1100" b="0">
+              <a:defRPr sz="1200" b="0">
                 <a:solidFill>
                   <a:srgbClr val="37474F"/>
                 </a:solidFill>
@@ -11196,7 +11860,7 @@
           <a:lstStyle/>
           <a:p>
             <a:pPr>
-              <a:defRPr sz="2800" b="1">
+              <a:defRPr sz="3000" b="1">
                 <a:solidFill>
                   <a:srgbClr val="0D2B45"/>
                 </a:solidFill>
@@ -11218,7 +11882,7 @@
         <p:spPr>
           <a:xfrm>
             <a:off x="502920" y="1344168"/>
-            <a:ext cx="11155680" cy="2011680"/>
+            <a:ext cx="11155680" cy="5010912"/>
           </a:xfrm>
           <a:prstGeom prst="roundRect">
             <a:avLst/>
@@ -11263,7 +11927,7 @@
         <p:spPr>
           <a:xfrm>
             <a:off x="777240" y="1463040"/>
-            <a:ext cx="10424160" cy="1828800"/>
+            <a:ext cx="10424160" cy="4782312"/>
           </a:xfrm>
           <a:prstGeom prst="rect">
             <a:avLst/>
@@ -11283,7 +11947,7 @@
               <a:spcAft>
                 <a:spcPts val="800"/>
               </a:spcAft>
-              <a:defRPr sz="1700" b="0">
+              <a:defRPr sz="1900" b="0">
                 <a:solidFill>
                   <a:srgbClr val="37474F"/>
                 </a:solidFill>
@@ -11302,7 +11966,7 @@
               <a:spcAft>
                 <a:spcPts val="800"/>
               </a:spcAft>
-              <a:defRPr sz="1700" b="0">
+              <a:defRPr sz="1900" b="0">
                 <a:solidFill>
                   <a:srgbClr val="37474F"/>
                 </a:solidFill>
@@ -11321,7 +11985,7 @@
               <a:spcAft>
                 <a:spcPts val="800"/>
               </a:spcAft>
-              <a:defRPr sz="1700" b="0">
+              <a:defRPr sz="1900" b="0">
                 <a:solidFill>
                   <a:srgbClr val="37474F"/>
                 </a:solidFill>
@@ -11340,7 +12004,7 @@
               <a:spcAft>
                 <a:spcPts val="800"/>
               </a:spcAft>
-              <a:defRPr sz="1700" b="0">
+              <a:defRPr sz="1900" b="0">
                 <a:solidFill>
                   <a:srgbClr val="37474F"/>
                 </a:solidFill>
@@ -11509,7 +12173,7 @@
         </p:nvSpPr>
         <p:spPr>
           <a:xfrm>
-            <a:off x="594360" y="438912"/>
+            <a:off x="594360" y="347472"/>
             <a:ext cx="10972800" cy="868680"/>
           </a:xfrm>
           <a:prstGeom prst="rect">
@@ -11545,8 +12209,8 @@
         </p:nvSpPr>
         <p:spPr>
           <a:xfrm>
-            <a:off x="2928975" y="1426464"/>
-            <a:ext cx="6333744" cy="4123944"/>
+            <a:off x="1667103" y="1298448"/>
+            <a:ext cx="8857488" cy="5733288"/>
           </a:xfrm>
           <a:prstGeom prst="roundRect">
             <a:avLst/>
@@ -11598,8 +12262,8 @@
         </p:blipFill>
         <p:spPr>
           <a:xfrm>
-            <a:off x="3002127" y="1499616"/>
-            <a:ext cx="6187440" cy="3977639"/>
+            <a:off x="1721967" y="1353312"/>
+            <a:ext cx="8747760" cy="5623560"/>
           </a:xfrm>
           <a:prstGeom prst="rect">
             <a:avLst/>
@@ -11614,7 +12278,7 @@
         </p:nvSpPr>
         <p:spPr>
           <a:xfrm>
-            <a:off x="594360" y="5687568"/>
+            <a:off x="594360" y="7168896"/>
             <a:ext cx="10972800" cy="411480"/>
           </a:xfrm>
           <a:prstGeom prst="rect">
@@ -11629,7 +12293,7 @@
           <a:lstStyle/>
           <a:p>
             <a:pPr>
-              <a:defRPr sz="1100" b="0">
+              <a:defRPr sz="1200" b="0">
                 <a:solidFill>
                   <a:srgbClr val="37474F"/>
                 </a:solidFill>
@@ -11849,7 +12513,7 @@
           <a:lstStyle/>
           <a:p>
             <a:pPr>
-              <a:defRPr sz="2800" b="1">
+              <a:defRPr sz="3000" b="1">
                 <a:solidFill>
                   <a:srgbClr val="0D2B45"/>
                 </a:solidFill>
@@ -11871,7 +12535,7 @@
         <p:spPr>
           <a:xfrm>
             <a:off x="502920" y="1344168"/>
-            <a:ext cx="11155680" cy="1691639"/>
+            <a:ext cx="11155680" cy="5010912"/>
           </a:xfrm>
           <a:prstGeom prst="roundRect">
             <a:avLst/>
@@ -11916,7 +12580,7 @@
         <p:spPr>
           <a:xfrm>
             <a:off x="777240" y="1463040"/>
-            <a:ext cx="10424160" cy="1508759"/>
+            <a:ext cx="10424160" cy="4782312"/>
           </a:xfrm>
           <a:prstGeom prst="rect">
             <a:avLst/>
@@ -11936,7 +12600,7 @@
               <a:spcAft>
                 <a:spcPts val="800"/>
               </a:spcAft>
-              <a:defRPr sz="1700" b="0">
+              <a:defRPr sz="1900" b="0">
                 <a:solidFill>
                   <a:srgbClr val="37474F"/>
                 </a:solidFill>
@@ -11955,7 +12619,7 @@
               <a:spcAft>
                 <a:spcPts val="800"/>
               </a:spcAft>
-              <a:defRPr sz="1700" b="0">
+              <a:defRPr sz="1900" b="0">
                 <a:solidFill>
                   <a:srgbClr val="37474F"/>
                 </a:solidFill>
@@ -11974,7 +12638,7 @@
               <a:spcAft>
                 <a:spcPts val="800"/>
               </a:spcAft>
-              <a:defRPr sz="1700" b="0">
+              <a:defRPr sz="1900" b="0">
                 <a:solidFill>
                   <a:srgbClr val="37474F"/>
                 </a:solidFill>
@@ -12143,7 +12807,7 @@
         </p:nvSpPr>
         <p:spPr>
           <a:xfrm>
-            <a:off x="594360" y="438912"/>
+            <a:off x="594360" y="347472"/>
             <a:ext cx="10972800" cy="868680"/>
           </a:xfrm>
           <a:prstGeom prst="rect">
@@ -12179,8 +12843,8 @@
         </p:nvSpPr>
         <p:spPr>
           <a:xfrm>
-            <a:off x="2928975" y="1426464"/>
-            <a:ext cx="6333744" cy="4123944"/>
+            <a:off x="1667103" y="1298448"/>
+            <a:ext cx="8857488" cy="5733288"/>
           </a:xfrm>
           <a:prstGeom prst="roundRect">
             <a:avLst/>
@@ -12232,8 +12896,8 @@
         </p:blipFill>
         <p:spPr>
           <a:xfrm>
-            <a:off x="3002127" y="1499616"/>
-            <a:ext cx="6187440" cy="3977639"/>
+            <a:off x="1721967" y="1353312"/>
+            <a:ext cx="8747760" cy="5623560"/>
           </a:xfrm>
           <a:prstGeom prst="rect">
             <a:avLst/>
@@ -12248,7 +12912,7 @@
         </p:nvSpPr>
         <p:spPr>
           <a:xfrm>
-            <a:off x="594360" y="5687568"/>
+            <a:off x="594360" y="7168896"/>
             <a:ext cx="10972800" cy="411480"/>
           </a:xfrm>
           <a:prstGeom prst="rect">
@@ -12263,7 +12927,7 @@
           <a:lstStyle/>
           <a:p>
             <a:pPr>
-              <a:defRPr sz="1100" b="0">
+              <a:defRPr sz="1200" b="0">
                 <a:solidFill>
                   <a:srgbClr val="37474F"/>
                 </a:solidFill>
@@ -12468,7 +13132,7 @@
         </p:nvSpPr>
         <p:spPr>
           <a:xfrm>
-            <a:off x="594360" y="438912"/>
+            <a:off x="594360" y="347472"/>
             <a:ext cx="10972800" cy="868680"/>
           </a:xfrm>
           <a:prstGeom prst="rect">
@@ -12504,8 +13168,8 @@
         </p:nvSpPr>
         <p:spPr>
           <a:xfrm>
-            <a:off x="2928975" y="1426464"/>
-            <a:ext cx="6333744" cy="4123944"/>
+            <a:off x="1667103" y="1298448"/>
+            <a:ext cx="8857488" cy="5733288"/>
           </a:xfrm>
           <a:prstGeom prst="roundRect">
             <a:avLst/>
@@ -12557,8 +13221,8 @@
         </p:blipFill>
         <p:spPr>
           <a:xfrm>
-            <a:off x="3002127" y="1499616"/>
-            <a:ext cx="6187440" cy="3977639"/>
+            <a:off x="1721967" y="1353312"/>
+            <a:ext cx="8747760" cy="5623560"/>
           </a:xfrm>
           <a:prstGeom prst="rect">
             <a:avLst/>
@@ -12573,7 +13237,7 @@
         </p:nvSpPr>
         <p:spPr>
           <a:xfrm>
-            <a:off x="594360" y="5687568"/>
+            <a:off x="594360" y="7168896"/>
             <a:ext cx="10972800" cy="411480"/>
           </a:xfrm>
           <a:prstGeom prst="rect">
@@ -12588,7 +13252,7 @@
           <a:lstStyle/>
           <a:p>
             <a:pPr>
-              <a:defRPr sz="1100" b="0">
+              <a:defRPr sz="1200" b="0">
                 <a:solidFill>
                   <a:srgbClr val="37474F"/>
                 </a:solidFill>
@@ -12808,7 +13472,7 @@
           <a:lstStyle/>
           <a:p>
             <a:pPr>
-              <a:defRPr sz="2800" b="1">
+              <a:defRPr sz="3000" b="1">
                 <a:solidFill>
                   <a:srgbClr val="0D2B45"/>
                 </a:solidFill>
@@ -12830,7 +13494,7 @@
         <p:spPr>
           <a:xfrm>
             <a:off x="502920" y="1344168"/>
-            <a:ext cx="11155680" cy="1691639"/>
+            <a:ext cx="11155680" cy="5010912"/>
           </a:xfrm>
           <a:prstGeom prst="roundRect">
             <a:avLst/>
@@ -12875,7 +13539,7 @@
         <p:spPr>
           <a:xfrm>
             <a:off x="777240" y="1463040"/>
-            <a:ext cx="10424160" cy="1508759"/>
+            <a:ext cx="10424160" cy="4782312"/>
           </a:xfrm>
           <a:prstGeom prst="rect">
             <a:avLst/>
@@ -12895,7 +13559,7 @@
               <a:spcAft>
                 <a:spcPts val="800"/>
               </a:spcAft>
-              <a:defRPr sz="1700" b="0">
+              <a:defRPr sz="1900" b="0">
                 <a:solidFill>
                   <a:srgbClr val="37474F"/>
                 </a:solidFill>
@@ -12914,7 +13578,7 @@
               <a:spcAft>
                 <a:spcPts val="800"/>
               </a:spcAft>
-              <a:defRPr sz="1700" b="0">
+              <a:defRPr sz="1900" b="0">
                 <a:solidFill>
                   <a:srgbClr val="37474F"/>
                 </a:solidFill>
@@ -12933,7 +13597,7 @@
               <a:spcAft>
                 <a:spcPts val="800"/>
               </a:spcAft>
-              <a:defRPr sz="1700" b="0">
+              <a:defRPr sz="1900" b="0">
                 <a:solidFill>
                   <a:srgbClr val="37474F"/>
                 </a:solidFill>
@@ -13170,7 +13834,7 @@
           <a:lstStyle/>
           <a:p>
             <a:pPr algn="r">
-              <a:defRPr sz="1000" b="0">
+              <a:defRPr sz="1100" b="0">
                 <a:solidFill>
                   <a:srgbClr val="78909C"/>
                 </a:solidFill>
@@ -13206,7 +13870,7 @@
           <a:lstStyle/>
           <a:p>
             <a:pPr>
-              <a:defRPr sz="2400" b="1">
+              <a:defRPr sz="2600" b="1">
                 <a:solidFill>
                   <a:srgbClr val="0D2B45"/>
                 </a:solidFill>
@@ -13228,7 +13892,7 @@
         <p:spPr>
           <a:xfrm>
             <a:off x="502920" y="1554480"/>
-            <a:ext cx="11155680" cy="2651759"/>
+            <a:ext cx="11155680" cy="4800600"/>
           </a:xfrm>
           <a:prstGeom prst="roundRect">
             <a:avLst/>
@@ -13273,7 +13937,7 @@
         <p:spPr>
           <a:xfrm>
             <a:off x="777240" y="1673352"/>
-            <a:ext cx="10424160" cy="2468879"/>
+            <a:ext cx="10424160" cy="4572000"/>
           </a:xfrm>
           <a:prstGeom prst="rect">
             <a:avLst/>
@@ -13293,7 +13957,7 @@
               <a:spcAft>
                 <a:spcPts val="500"/>
               </a:spcAft>
-              <a:defRPr sz="1500" b="0">
+              <a:defRPr sz="1600" b="0">
                 <a:solidFill>
                   <a:srgbClr val="37474F"/>
                 </a:solidFill>
@@ -13312,7 +13976,7 @@
               <a:spcAft>
                 <a:spcPts val="500"/>
               </a:spcAft>
-              <a:defRPr sz="1500" b="0">
+              <a:defRPr sz="1600" b="0">
                 <a:solidFill>
                   <a:srgbClr val="37474F"/>
                 </a:solidFill>
@@ -13331,7 +13995,7 @@
               <a:spcAft>
                 <a:spcPts val="500"/>
               </a:spcAft>
-              <a:defRPr sz="1500" b="0">
+              <a:defRPr sz="1600" b="0">
                 <a:solidFill>
                   <a:srgbClr val="37474F"/>
                 </a:solidFill>
@@ -13350,7 +14014,7 @@
               <a:spcAft>
                 <a:spcPts val="500"/>
               </a:spcAft>
-              <a:defRPr sz="1500" b="0">
+              <a:defRPr sz="1600" b="0">
                 <a:solidFill>
                   <a:srgbClr val="37474F"/>
                 </a:solidFill>
@@ -13369,7 +14033,7 @@
               <a:spcAft>
                 <a:spcPts val="500"/>
               </a:spcAft>
-              <a:defRPr sz="1500" b="0">
+              <a:defRPr sz="1600" b="0">
                 <a:solidFill>
                   <a:srgbClr val="37474F"/>
                 </a:solidFill>
@@ -13388,7 +14052,7 @@
               <a:spcAft>
                 <a:spcPts val="500"/>
               </a:spcAft>
-              <a:defRPr sz="1500" b="0">
+              <a:defRPr sz="1600" b="0">
                 <a:solidFill>
                   <a:srgbClr val="37474F"/>
                 </a:solidFill>
@@ -13661,7 +14325,7 @@
           <a:lstStyle/>
           <a:p>
             <a:pPr algn="r">
-              <a:defRPr sz="1000" b="0">
+              <a:defRPr sz="1100" b="0">
                 <a:solidFill>
                   <a:srgbClr val="78909C"/>
                 </a:solidFill>
@@ -13697,7 +14361,7 @@
           <a:lstStyle/>
           <a:p>
             <a:pPr>
-              <a:defRPr sz="2400" b="1">
+              <a:defRPr sz="2600" b="1">
                 <a:solidFill>
                   <a:srgbClr val="0D2B45"/>
                 </a:solidFill>
@@ -13719,7 +14383,7 @@
         <p:spPr>
           <a:xfrm>
             <a:off x="502920" y="1554480"/>
-            <a:ext cx="11155680" cy="2651759"/>
+            <a:ext cx="11155680" cy="4800600"/>
           </a:xfrm>
           <a:prstGeom prst="roundRect">
             <a:avLst/>
@@ -13764,7 +14428,7 @@
         <p:spPr>
           <a:xfrm>
             <a:off x="777240" y="1673352"/>
-            <a:ext cx="10424160" cy="2468879"/>
+            <a:ext cx="10424160" cy="4572000"/>
           </a:xfrm>
           <a:prstGeom prst="rect">
             <a:avLst/>
@@ -13784,7 +14448,7 @@
               <a:spcAft>
                 <a:spcPts val="500"/>
               </a:spcAft>
-              <a:defRPr sz="1500" b="0">
+              <a:defRPr sz="1600" b="0">
                 <a:solidFill>
                   <a:srgbClr val="37474F"/>
                 </a:solidFill>
@@ -13803,7 +14467,7 @@
               <a:spcAft>
                 <a:spcPts val="500"/>
               </a:spcAft>
-              <a:defRPr sz="1500" b="0">
+              <a:defRPr sz="1600" b="0">
                 <a:solidFill>
                   <a:srgbClr val="37474F"/>
                 </a:solidFill>
@@ -13822,7 +14486,7 @@
               <a:spcAft>
                 <a:spcPts val="500"/>
               </a:spcAft>
-              <a:defRPr sz="1500" b="0">
+              <a:defRPr sz="1600" b="0">
                 <a:solidFill>
                   <a:srgbClr val="37474F"/>
                 </a:solidFill>
@@ -13841,7 +14505,7 @@
               <a:spcAft>
                 <a:spcPts val="500"/>
               </a:spcAft>
-              <a:defRPr sz="1500" b="0">
+              <a:defRPr sz="1600" b="0">
                 <a:solidFill>
                   <a:srgbClr val="37474F"/>
                 </a:solidFill>
@@ -13860,7 +14524,7 @@
               <a:spcAft>
                 <a:spcPts val="500"/>
               </a:spcAft>
-              <a:defRPr sz="1500" b="0">
+              <a:defRPr sz="1600" b="0">
                 <a:solidFill>
                   <a:srgbClr val="37474F"/>
                 </a:solidFill>
@@ -13879,7 +14543,7 @@
               <a:spcAft>
                 <a:spcPts val="500"/>
               </a:spcAft>
-              <a:defRPr sz="1500" b="0">
+              <a:defRPr sz="1600" b="0">
                 <a:solidFill>
                   <a:srgbClr val="37474F"/>
                 </a:solidFill>
@@ -14099,7 +14763,7 @@
           <a:lstStyle/>
           <a:p>
             <a:pPr algn="ctr">
-              <a:defRPr sz="3600" b="1">
+              <a:defRPr sz="3800" b="1">
                 <a:solidFill>
                   <a:srgbClr val="FFFFFF"/>
                 </a:solidFill>
@@ -14135,7 +14799,7 @@
           <a:lstStyle/>
           <a:p>
             <a:pPr algn="ctr">
-              <a:defRPr sz="2000" b="0">
+              <a:defRPr sz="2200" b="0">
                 <a:solidFill>
                   <a:srgbClr val="B2EBF2"/>
                 </a:solidFill>
@@ -14225,7 +14889,7 @@
         </p:nvSpPr>
         <p:spPr>
           <a:xfrm>
-            <a:off x="594360" y="438912"/>
+            <a:off x="594360" y="347472"/>
             <a:ext cx="10972800" cy="868680"/>
           </a:xfrm>
           <a:prstGeom prst="rect">
@@ -14261,8 +14925,8 @@
         </p:nvSpPr>
         <p:spPr>
           <a:xfrm>
-            <a:off x="2453018" y="1426464"/>
-            <a:ext cx="7285657" cy="4123944"/>
+            <a:off x="994198" y="1298448"/>
+            <a:ext cx="10203297" cy="5733288"/>
           </a:xfrm>
           <a:prstGeom prst="roundRect">
             <a:avLst/>
@@ -14314,8 +14978,8 @@
         </p:blipFill>
         <p:spPr>
           <a:xfrm>
-            <a:off x="2526170" y="1499616"/>
-            <a:ext cx="7139353" cy="3977639"/>
+            <a:off x="1049062" y="1353312"/>
+            <a:ext cx="10093569" cy="5623560"/>
           </a:xfrm>
           <a:prstGeom prst="rect">
             <a:avLst/>
@@ -14330,7 +14994,7 @@
         </p:nvSpPr>
         <p:spPr>
           <a:xfrm>
-            <a:off x="594360" y="5687568"/>
+            <a:off x="594360" y="7168896"/>
             <a:ext cx="10972800" cy="411480"/>
           </a:xfrm>
           <a:prstGeom prst="rect">
@@ -14345,7 +15009,7 @@
           <a:lstStyle/>
           <a:p>
             <a:pPr>
-              <a:defRPr sz="1100" b="0">
+              <a:defRPr sz="1200" b="0">
                 <a:solidFill>
                   <a:srgbClr val="37474F"/>
                 </a:solidFill>
@@ -14550,7 +15214,7 @@
         </p:nvSpPr>
         <p:spPr>
           <a:xfrm>
-            <a:off x="594360" y="438912"/>
+            <a:off x="594360" y="347472"/>
             <a:ext cx="10972800" cy="868680"/>
           </a:xfrm>
           <a:prstGeom prst="rect">
@@ -14586,8 +15250,8 @@
         </p:nvSpPr>
         <p:spPr>
           <a:xfrm>
-            <a:off x="2928975" y="1426464"/>
-            <a:ext cx="6333744" cy="4123944"/>
+            <a:off x="1667103" y="1298448"/>
+            <a:ext cx="8857488" cy="5733288"/>
           </a:xfrm>
           <a:prstGeom prst="roundRect">
             <a:avLst/>
@@ -14639,8 +15303,8 @@
         </p:blipFill>
         <p:spPr>
           <a:xfrm>
-            <a:off x="3002127" y="1499616"/>
-            <a:ext cx="6187440" cy="3977639"/>
+            <a:off x="1721967" y="1353312"/>
+            <a:ext cx="8747760" cy="5623560"/>
           </a:xfrm>
           <a:prstGeom prst="rect">
             <a:avLst/>
@@ -14655,7 +15319,7 @@
         </p:nvSpPr>
         <p:spPr>
           <a:xfrm>
-            <a:off x="594360" y="5687568"/>
+            <a:off x="594360" y="7168896"/>
             <a:ext cx="10972800" cy="411480"/>
           </a:xfrm>
           <a:prstGeom prst="rect">
@@ -14670,7 +15334,7 @@
           <a:lstStyle/>
           <a:p>
             <a:pPr>
-              <a:defRPr sz="1100" b="0">
+              <a:defRPr sz="1200" b="0">
                 <a:solidFill>
                   <a:srgbClr val="37474F"/>
                 </a:solidFill>
@@ -14890,7 +15554,7 @@
           <a:lstStyle/>
           <a:p>
             <a:pPr>
-              <a:defRPr sz="2800" b="1">
+              <a:defRPr sz="3000" b="1">
                 <a:solidFill>
                   <a:srgbClr val="0D2B45"/>
                 </a:solidFill>
@@ -14912,7 +15576,7 @@
         <p:spPr>
           <a:xfrm>
             <a:off x="502920" y="1344168"/>
-            <a:ext cx="11155680" cy="1691639"/>
+            <a:ext cx="11155680" cy="5010912"/>
           </a:xfrm>
           <a:prstGeom prst="roundRect">
             <a:avLst/>
@@ -14957,7 +15621,7 @@
         <p:spPr>
           <a:xfrm>
             <a:off x="777240" y="1463040"/>
-            <a:ext cx="10424160" cy="1508759"/>
+            <a:ext cx="10424160" cy="4782312"/>
           </a:xfrm>
           <a:prstGeom prst="rect">
             <a:avLst/>
@@ -14977,7 +15641,7 @@
               <a:spcAft>
                 <a:spcPts val="800"/>
               </a:spcAft>
-              <a:defRPr sz="1700" b="0">
+              <a:defRPr sz="1900" b="0">
                 <a:solidFill>
                   <a:srgbClr val="37474F"/>
                 </a:solidFill>
@@ -14996,7 +15660,7 @@
               <a:spcAft>
                 <a:spcPts val="800"/>
               </a:spcAft>
-              <a:defRPr sz="1700" b="0">
+              <a:defRPr sz="1900" b="0">
                 <a:solidFill>
                   <a:srgbClr val="37474F"/>
                 </a:solidFill>
@@ -15015,7 +15679,7 @@
               <a:spcAft>
                 <a:spcPts val="800"/>
               </a:spcAft>
-              <a:defRPr sz="1700" b="0">
+              <a:defRPr sz="1900" b="0">
                 <a:solidFill>
                   <a:srgbClr val="37474F"/>
                 </a:solidFill>
@@ -15199,7 +15863,7 @@
           <a:lstStyle/>
           <a:p>
             <a:pPr>
-              <a:defRPr sz="2800" b="1">
+              <a:defRPr sz="3000" b="1">
                 <a:solidFill>
                   <a:srgbClr val="0D2B45"/>
                 </a:solidFill>
@@ -15221,7 +15885,7 @@
         <p:spPr>
           <a:xfrm>
             <a:off x="502920" y="1344168"/>
-            <a:ext cx="11155680" cy="2011680"/>
+            <a:ext cx="11155680" cy="5010912"/>
           </a:xfrm>
           <a:prstGeom prst="roundRect">
             <a:avLst/>
@@ -15266,7 +15930,7 @@
         <p:spPr>
           <a:xfrm>
             <a:off x="777240" y="1463040"/>
-            <a:ext cx="10424160" cy="1828800"/>
+            <a:ext cx="10424160" cy="4782312"/>
           </a:xfrm>
           <a:prstGeom prst="rect">
             <a:avLst/>
@@ -15286,7 +15950,7 @@
               <a:spcAft>
                 <a:spcPts val="800"/>
               </a:spcAft>
-              <a:defRPr sz="1700" b="0">
+              <a:defRPr sz="1900" b="0">
                 <a:solidFill>
                   <a:srgbClr val="37474F"/>
                 </a:solidFill>
@@ -15305,7 +15969,7 @@
               <a:spcAft>
                 <a:spcPts val="800"/>
               </a:spcAft>
-              <a:defRPr sz="1700" b="0">
+              <a:defRPr sz="1900" b="0">
                 <a:solidFill>
                   <a:srgbClr val="37474F"/>
                 </a:solidFill>
@@ -15324,7 +15988,7 @@
               <a:spcAft>
                 <a:spcPts val="800"/>
               </a:spcAft>
-              <a:defRPr sz="1700" b="0">
+              <a:defRPr sz="1900" b="0">
                 <a:solidFill>
                   <a:srgbClr val="37474F"/>
                 </a:solidFill>
@@ -15343,7 +16007,7 @@
               <a:spcAft>
                 <a:spcPts val="800"/>
               </a:spcAft>
-              <a:defRPr sz="1700" b="0">
+              <a:defRPr sz="1900" b="0">
                 <a:solidFill>
                   <a:srgbClr val="37474F"/>
                 </a:solidFill>
@@ -15580,7 +16244,7 @@
           <a:lstStyle/>
           <a:p>
             <a:pPr algn="r">
-              <a:defRPr sz="1000" b="0">
+              <a:defRPr sz="1100" b="0">
                 <a:solidFill>
                   <a:srgbClr val="78909C"/>
                 </a:solidFill>
@@ -15616,7 +16280,7 @@
           <a:lstStyle/>
           <a:p>
             <a:pPr>
-              <a:defRPr sz="2400" b="1">
+              <a:defRPr sz="2600" b="1">
                 <a:solidFill>
                   <a:srgbClr val="0D2B45"/>
                 </a:solidFill>
@@ -15638,7 +16302,7 @@
         <p:spPr>
           <a:xfrm>
             <a:off x="502920" y="1554480"/>
-            <a:ext cx="11155680" cy="2651759"/>
+            <a:ext cx="11155680" cy="4800600"/>
           </a:xfrm>
           <a:prstGeom prst="roundRect">
             <a:avLst/>
@@ -15683,7 +16347,7 @@
         <p:spPr>
           <a:xfrm>
             <a:off x="777240" y="1673352"/>
-            <a:ext cx="10424160" cy="2468879"/>
+            <a:ext cx="10424160" cy="4572000"/>
           </a:xfrm>
           <a:prstGeom prst="rect">
             <a:avLst/>
@@ -15703,7 +16367,7 @@
               <a:spcAft>
                 <a:spcPts val="500"/>
               </a:spcAft>
-              <a:defRPr sz="1500" b="0">
+              <a:defRPr sz="1600" b="0">
                 <a:solidFill>
                   <a:srgbClr val="37474F"/>
                 </a:solidFill>
@@ -15722,7 +16386,7 @@
               <a:spcAft>
                 <a:spcPts val="500"/>
               </a:spcAft>
-              <a:defRPr sz="1500" b="0">
+              <a:defRPr sz="1600" b="0">
                 <a:solidFill>
                   <a:srgbClr val="37474F"/>
                 </a:solidFill>
@@ -15741,7 +16405,7 @@
               <a:spcAft>
                 <a:spcPts val="500"/>
               </a:spcAft>
-              <a:defRPr sz="1500" b="0">
+              <a:defRPr sz="1600" b="0">
                 <a:solidFill>
                   <a:srgbClr val="37474F"/>
                 </a:solidFill>
@@ -15760,7 +16424,7 @@
               <a:spcAft>
                 <a:spcPts val="500"/>
               </a:spcAft>
-              <a:defRPr sz="1500" b="0">
+              <a:defRPr sz="1600" b="0">
                 <a:solidFill>
                   <a:srgbClr val="37474F"/>
                 </a:solidFill>
@@ -15779,7 +16443,7 @@
               <a:spcAft>
                 <a:spcPts val="500"/>
               </a:spcAft>
-              <a:defRPr sz="1500" b="0">
+              <a:defRPr sz="1600" b="0">
                 <a:solidFill>
                   <a:srgbClr val="37474F"/>
                 </a:solidFill>
@@ -15798,7 +16462,7 @@
               <a:spcAft>
                 <a:spcPts val="500"/>
               </a:spcAft>
-              <a:defRPr sz="1500" b="0">
+              <a:defRPr sz="1600" b="0">
                 <a:solidFill>
                   <a:srgbClr val="37474F"/>
                 </a:solidFill>
@@ -16018,7 +16682,7 @@
           <a:lstStyle/>
           <a:p>
             <a:pPr algn="ctr">
-              <a:defRPr sz="3600" b="1">
+              <a:defRPr sz="3800" b="1">
                 <a:solidFill>
                   <a:srgbClr val="FFFFFF"/>
                 </a:solidFill>
@@ -16054,7 +16718,7 @@
           <a:lstStyle/>
           <a:p>
             <a:pPr algn="ctr">
-              <a:defRPr sz="2000" b="0">
+              <a:defRPr sz="2200" b="0">
                 <a:solidFill>
                   <a:srgbClr val="B2EBF2"/>
                 </a:solidFill>
@@ -16159,7 +16823,7 @@
           <a:lstStyle/>
           <a:p>
             <a:pPr>
-              <a:defRPr sz="2800" b="1">
+              <a:defRPr sz="3000" b="1">
                 <a:solidFill>
                   <a:srgbClr val="0D2B45"/>
                 </a:solidFill>
@@ -16181,7 +16845,7 @@
         <p:spPr>
           <a:xfrm>
             <a:off x="502920" y="1344168"/>
-            <a:ext cx="11155680" cy="1691639"/>
+            <a:ext cx="11155680" cy="5010912"/>
           </a:xfrm>
           <a:prstGeom prst="roundRect">
             <a:avLst/>
@@ -16226,7 +16890,7 @@
         <p:spPr>
           <a:xfrm>
             <a:off x="777240" y="1463040"/>
-            <a:ext cx="10424160" cy="1508759"/>
+            <a:ext cx="10424160" cy="4782312"/>
           </a:xfrm>
           <a:prstGeom prst="rect">
             <a:avLst/>
@@ -16246,7 +16910,7 @@
               <a:spcAft>
                 <a:spcPts val="800"/>
               </a:spcAft>
-              <a:defRPr sz="1300" b="0">
+              <a:defRPr sz="1400" b="0">
                 <a:solidFill>
                   <a:srgbClr val="0D2B45"/>
                 </a:solidFill>
@@ -16265,7 +16929,7 @@
               <a:spcAft>
                 <a:spcPts val="800"/>
               </a:spcAft>
-              <a:defRPr sz="1300" b="0">
+              <a:defRPr sz="1400" b="0">
                 <a:solidFill>
                   <a:srgbClr val="0D2B45"/>
                 </a:solidFill>
@@ -16284,7 +16948,7 @@
               <a:spcAft>
                 <a:spcPts val="800"/>
               </a:spcAft>
-              <a:defRPr sz="1700" b="0">
+              <a:defRPr sz="1900" b="0">
                 <a:solidFill>
                   <a:srgbClr val="37474F"/>
                 </a:solidFill>
@@ -16468,7 +17132,7 @@
           <a:lstStyle/>
           <a:p>
             <a:pPr>
-              <a:defRPr sz="2800" b="1">
+              <a:defRPr sz="3000" b="1">
                 <a:solidFill>
                   <a:srgbClr val="0D2B45"/>
                 </a:solidFill>
@@ -16490,7 +17154,7 @@
         <p:spPr>
           <a:xfrm>
             <a:off x="502920" y="1344168"/>
-            <a:ext cx="11155680" cy="2331720"/>
+            <a:ext cx="11155680" cy="5010912"/>
           </a:xfrm>
           <a:prstGeom prst="roundRect">
             <a:avLst/>
@@ -16535,7 +17199,7 @@
         <p:spPr>
           <a:xfrm>
             <a:off x="777240" y="1463040"/>
-            <a:ext cx="10424160" cy="2148840"/>
+            <a:ext cx="10424160" cy="4782312"/>
           </a:xfrm>
           <a:prstGeom prst="rect">
             <a:avLst/>
@@ -16555,7 +17219,7 @@
               <a:spcAft>
                 <a:spcPts val="800"/>
               </a:spcAft>
-              <a:defRPr sz="1700" b="0">
+              <a:defRPr sz="1900" b="0">
                 <a:solidFill>
                   <a:srgbClr val="37474F"/>
                 </a:solidFill>
@@ -16574,7 +17238,7 @@
               <a:spcAft>
                 <a:spcPts val="800"/>
               </a:spcAft>
-              <a:defRPr sz="1700" b="0">
+              <a:defRPr sz="1900" b="0">
                 <a:solidFill>
                   <a:srgbClr val="37474F"/>
                 </a:solidFill>
@@ -16593,7 +17257,7 @@
               <a:spcAft>
                 <a:spcPts val="800"/>
               </a:spcAft>
-              <a:defRPr sz="1700" b="0">
+              <a:defRPr sz="1900" b="0">
                 <a:solidFill>
                   <a:srgbClr val="37474F"/>
                 </a:solidFill>
@@ -16612,7 +17276,7 @@
               <a:spcAft>
                 <a:spcPts val="800"/>
               </a:spcAft>
-              <a:defRPr sz="1700" b="0">
+              <a:defRPr sz="1900" b="0">
                 <a:solidFill>
                   <a:srgbClr val="37474F"/>
                 </a:solidFill>
@@ -16631,7 +17295,7 @@
               <a:spcAft>
                 <a:spcPts val="800"/>
               </a:spcAft>
-              <a:defRPr sz="1700" b="0">
+              <a:defRPr sz="1900" b="0">
                 <a:solidFill>
                   <a:srgbClr val="37474F"/>
                 </a:solidFill>
@@ -16868,7 +17532,7 @@
           <a:lstStyle/>
           <a:p>
             <a:pPr algn="r">
-              <a:defRPr sz="1000" b="0">
+              <a:defRPr sz="1100" b="0">
                 <a:solidFill>
                   <a:srgbClr val="78909C"/>
                 </a:solidFill>
@@ -16904,7 +17568,7 @@
           <a:lstStyle/>
           <a:p>
             <a:pPr>
-              <a:defRPr sz="2400" b="1">
+              <a:defRPr sz="2600" b="1">
                 <a:solidFill>
                   <a:srgbClr val="0D2B45"/>
                 </a:solidFill>
@@ -16926,7 +17590,7 @@
         <p:spPr>
           <a:xfrm>
             <a:off x="502920" y="1554480"/>
-            <a:ext cx="11155680" cy="2651759"/>
+            <a:ext cx="11155680" cy="4800600"/>
           </a:xfrm>
           <a:prstGeom prst="roundRect">
             <a:avLst/>
@@ -16971,7 +17635,7 @@
         <p:spPr>
           <a:xfrm>
             <a:off x="777240" y="1673352"/>
-            <a:ext cx="10424160" cy="2468879"/>
+            <a:ext cx="10424160" cy="4572000"/>
           </a:xfrm>
           <a:prstGeom prst="rect">
             <a:avLst/>
@@ -16991,7 +17655,7 @@
               <a:spcAft>
                 <a:spcPts val="500"/>
               </a:spcAft>
-              <a:defRPr sz="1500" b="0">
+              <a:defRPr sz="1600" b="0">
                 <a:solidFill>
                   <a:srgbClr val="37474F"/>
                 </a:solidFill>
@@ -17010,7 +17674,7 @@
               <a:spcAft>
                 <a:spcPts val="500"/>
               </a:spcAft>
-              <a:defRPr sz="1500" b="0">
+              <a:defRPr sz="1600" b="0">
                 <a:solidFill>
                   <a:srgbClr val="37474F"/>
                 </a:solidFill>
@@ -17029,7 +17693,7 @@
               <a:spcAft>
                 <a:spcPts val="500"/>
               </a:spcAft>
-              <a:defRPr sz="1500" b="0">
+              <a:defRPr sz="1600" b="0">
                 <a:solidFill>
                   <a:srgbClr val="37474F"/>
                 </a:solidFill>
@@ -17048,7 +17712,7 @@
               <a:spcAft>
                 <a:spcPts val="500"/>
               </a:spcAft>
-              <a:defRPr sz="1500" b="0">
+              <a:defRPr sz="1600" b="0">
                 <a:solidFill>
                   <a:srgbClr val="37474F"/>
                 </a:solidFill>
@@ -17067,7 +17731,7 @@
               <a:spcAft>
                 <a:spcPts val="500"/>
               </a:spcAft>
-              <a:defRPr sz="1500" b="0">
+              <a:defRPr sz="1600" b="0">
                 <a:solidFill>
                   <a:srgbClr val="37474F"/>
                 </a:solidFill>
@@ -17086,7 +17750,7 @@
               <a:spcAft>
                 <a:spcPts val="500"/>
               </a:spcAft>
-              <a:defRPr sz="1500" b="0">
+              <a:defRPr sz="1600" b="0">
                 <a:solidFill>
                   <a:srgbClr val="37474F"/>
                 </a:solidFill>
@@ -17359,7 +18023,7 @@
           <a:lstStyle/>
           <a:p>
             <a:pPr algn="r">
-              <a:defRPr sz="1000" b="0">
+              <a:defRPr sz="1100" b="0">
                 <a:solidFill>
                   <a:srgbClr val="78909C"/>
                 </a:solidFill>
@@ -17395,7 +18059,7 @@
           <a:lstStyle/>
           <a:p>
             <a:pPr>
-              <a:defRPr sz="2400" b="1">
+              <a:defRPr sz="2600" b="1">
                 <a:solidFill>
                   <a:srgbClr val="0D2B45"/>
                 </a:solidFill>
@@ -17417,7 +18081,7 @@
         <p:spPr>
           <a:xfrm>
             <a:off x="502920" y="1554480"/>
-            <a:ext cx="11155680" cy="2651759"/>
+            <a:ext cx="11155680" cy="4800600"/>
           </a:xfrm>
           <a:prstGeom prst="roundRect">
             <a:avLst/>
@@ -17462,7 +18126,7 @@
         <p:spPr>
           <a:xfrm>
             <a:off x="777240" y="1673352"/>
-            <a:ext cx="10424160" cy="2468879"/>
+            <a:ext cx="10424160" cy="4572000"/>
           </a:xfrm>
           <a:prstGeom prst="rect">
             <a:avLst/>
@@ -17482,7 +18146,7 @@
               <a:spcAft>
                 <a:spcPts val="500"/>
               </a:spcAft>
-              <a:defRPr sz="1500" b="0">
+              <a:defRPr sz="1600" b="0">
                 <a:solidFill>
                   <a:srgbClr val="37474F"/>
                 </a:solidFill>
@@ -17501,7 +18165,7 @@
               <a:spcAft>
                 <a:spcPts val="500"/>
               </a:spcAft>
-              <a:defRPr sz="1500" b="0">
+              <a:defRPr sz="1600" b="0">
                 <a:solidFill>
                   <a:srgbClr val="37474F"/>
                 </a:solidFill>
@@ -17520,7 +18184,7 @@
               <a:spcAft>
                 <a:spcPts val="500"/>
               </a:spcAft>
-              <a:defRPr sz="1500" b="0">
+              <a:defRPr sz="1600" b="0">
                 <a:solidFill>
                   <a:srgbClr val="37474F"/>
                 </a:solidFill>
@@ -17539,7 +18203,7 @@
               <a:spcAft>
                 <a:spcPts val="500"/>
               </a:spcAft>
-              <a:defRPr sz="1500" b="0">
+              <a:defRPr sz="1600" b="0">
                 <a:solidFill>
                   <a:srgbClr val="37474F"/>
                 </a:solidFill>
@@ -17558,7 +18222,7 @@
               <a:spcAft>
                 <a:spcPts val="500"/>
               </a:spcAft>
-              <a:defRPr sz="1500" b="0">
+              <a:defRPr sz="1600" b="0">
                 <a:solidFill>
                   <a:srgbClr val="37474F"/>
                 </a:solidFill>
@@ -17577,7 +18241,7 @@
               <a:spcAft>
                 <a:spcPts val="500"/>
               </a:spcAft>
-              <a:defRPr sz="1500" b="0">
+              <a:defRPr sz="1600" b="0">
                 <a:solidFill>
                   <a:srgbClr val="37474F"/>
                 </a:solidFill>
@@ -17850,7 +18514,7 @@
           <a:lstStyle/>
           <a:p>
             <a:pPr algn="r">
-              <a:defRPr sz="1000" b="0">
+              <a:defRPr sz="1100" b="0">
                 <a:solidFill>
                   <a:srgbClr val="78909C"/>
                 </a:solidFill>
@@ -17886,7 +18550,7 @@
           <a:lstStyle/>
           <a:p>
             <a:pPr>
-              <a:defRPr sz="2400" b="1">
+              <a:defRPr sz="2600" b="1">
                 <a:solidFill>
                   <a:srgbClr val="0D2B45"/>
                 </a:solidFill>
@@ -17908,7 +18572,7 @@
         <p:spPr>
           <a:xfrm>
             <a:off x="502920" y="1554480"/>
-            <a:ext cx="11155680" cy="2651759"/>
+            <a:ext cx="11155680" cy="4800600"/>
           </a:xfrm>
           <a:prstGeom prst="roundRect">
             <a:avLst/>
@@ -17953,7 +18617,7 @@
         <p:spPr>
           <a:xfrm>
             <a:off x="777240" y="1673352"/>
-            <a:ext cx="10424160" cy="2468879"/>
+            <a:ext cx="10424160" cy="4572000"/>
           </a:xfrm>
           <a:prstGeom prst="rect">
             <a:avLst/>
@@ -17973,7 +18637,7 @@
               <a:spcAft>
                 <a:spcPts val="500"/>
               </a:spcAft>
-              <a:defRPr sz="1500" b="0">
+              <a:defRPr sz="1600" b="0">
                 <a:solidFill>
                   <a:srgbClr val="37474F"/>
                 </a:solidFill>
@@ -17992,7 +18656,7 @@
               <a:spcAft>
                 <a:spcPts val="500"/>
               </a:spcAft>
-              <a:defRPr sz="1500" b="0">
+              <a:defRPr sz="1600" b="0">
                 <a:solidFill>
                   <a:srgbClr val="37474F"/>
                 </a:solidFill>
@@ -18011,7 +18675,7 @@
               <a:spcAft>
                 <a:spcPts val="500"/>
               </a:spcAft>
-              <a:defRPr sz="1500" b="0">
+              <a:defRPr sz="1600" b="0">
                 <a:solidFill>
                   <a:srgbClr val="37474F"/>
                 </a:solidFill>
@@ -18030,7 +18694,7 @@
               <a:spcAft>
                 <a:spcPts val="500"/>
               </a:spcAft>
-              <a:defRPr sz="1500" b="0">
+              <a:defRPr sz="1600" b="0">
                 <a:solidFill>
                   <a:srgbClr val="37474F"/>
                 </a:solidFill>
@@ -18049,7 +18713,7 @@
               <a:spcAft>
                 <a:spcPts val="500"/>
               </a:spcAft>
-              <a:defRPr sz="1500" b="0">
+              <a:defRPr sz="1600" b="0">
                 <a:solidFill>
                   <a:srgbClr val="37474F"/>
                 </a:solidFill>
@@ -18068,7 +18732,7 @@
               <a:spcAft>
                 <a:spcPts val="500"/>
               </a:spcAft>
-              <a:defRPr sz="1500" b="0">
+              <a:defRPr sz="1600" b="0">
                 <a:solidFill>
                   <a:srgbClr val="37474F"/>
                 </a:solidFill>
@@ -18341,7 +19005,7 @@
           <a:lstStyle/>
           <a:p>
             <a:pPr algn="r">
-              <a:defRPr sz="1000" b="0">
+              <a:defRPr sz="1100" b="0">
                 <a:solidFill>
                   <a:srgbClr val="78909C"/>
                 </a:solidFill>
@@ -18377,7 +19041,7 @@
           <a:lstStyle/>
           <a:p>
             <a:pPr>
-              <a:defRPr sz="2400" b="1">
+              <a:defRPr sz="2600" b="1">
                 <a:solidFill>
                   <a:srgbClr val="0D2B45"/>
                 </a:solidFill>
@@ -18399,7 +19063,7 @@
         <p:spPr>
           <a:xfrm>
             <a:off x="502920" y="1554480"/>
-            <a:ext cx="11155680" cy="2651759"/>
+            <a:ext cx="11155680" cy="4800600"/>
           </a:xfrm>
           <a:prstGeom prst="roundRect">
             <a:avLst/>
@@ -18444,7 +19108,7 @@
         <p:spPr>
           <a:xfrm>
             <a:off x="777240" y="1673352"/>
-            <a:ext cx="10424160" cy="2468879"/>
+            <a:ext cx="10424160" cy="4572000"/>
           </a:xfrm>
           <a:prstGeom prst="rect">
             <a:avLst/>
@@ -18464,7 +19128,7 @@
               <a:spcAft>
                 <a:spcPts val="500"/>
               </a:spcAft>
-              <a:defRPr sz="1500" b="0">
+              <a:defRPr sz="1600" b="0">
                 <a:solidFill>
                   <a:srgbClr val="37474F"/>
                 </a:solidFill>
@@ -18483,7 +19147,7 @@
               <a:spcAft>
                 <a:spcPts val="500"/>
               </a:spcAft>
-              <a:defRPr sz="1500" b="0">
+              <a:defRPr sz="1600" b="0">
                 <a:solidFill>
                   <a:srgbClr val="37474F"/>
                 </a:solidFill>
@@ -18502,7 +19166,7 @@
               <a:spcAft>
                 <a:spcPts val="500"/>
               </a:spcAft>
-              <a:defRPr sz="1500" b="0">
+              <a:defRPr sz="1600" b="0">
                 <a:solidFill>
                   <a:srgbClr val="37474F"/>
                 </a:solidFill>
@@ -18521,7 +19185,7 @@
               <a:spcAft>
                 <a:spcPts val="500"/>
               </a:spcAft>
-              <a:defRPr sz="1500" b="0">
+              <a:defRPr sz="1600" b="0">
                 <a:solidFill>
                   <a:srgbClr val="37474F"/>
                 </a:solidFill>
@@ -18540,7 +19204,7 @@
               <a:spcAft>
                 <a:spcPts val="500"/>
               </a:spcAft>
-              <a:defRPr sz="1500" b="0">
+              <a:defRPr sz="1600" b="0">
                 <a:solidFill>
                   <a:srgbClr val="37474F"/>
                 </a:solidFill>
@@ -18559,7 +19223,7 @@
               <a:spcAft>
                 <a:spcPts val="500"/>
               </a:spcAft>
-              <a:defRPr sz="1500" b="0">
+              <a:defRPr sz="1600" b="0">
                 <a:solidFill>
                   <a:srgbClr val="37474F"/>
                 </a:solidFill>
@@ -18832,7 +19496,7 @@
           <a:lstStyle/>
           <a:p>
             <a:pPr algn="r">
-              <a:defRPr sz="1000" b="0">
+              <a:defRPr sz="1100" b="0">
                 <a:solidFill>
                   <a:srgbClr val="78909C"/>
                 </a:solidFill>
@@ -18868,7 +19532,7 @@
           <a:lstStyle/>
           <a:p>
             <a:pPr>
-              <a:defRPr sz="2400" b="1">
+              <a:defRPr sz="2600" b="1">
                 <a:solidFill>
                   <a:srgbClr val="0D2B45"/>
                 </a:solidFill>
@@ -18890,7 +19554,7 @@
         <p:spPr>
           <a:xfrm>
             <a:off x="502920" y="1554480"/>
-            <a:ext cx="11155680" cy="2651759"/>
+            <a:ext cx="11155680" cy="4800600"/>
           </a:xfrm>
           <a:prstGeom prst="roundRect">
             <a:avLst/>
@@ -18935,7 +19599,7 @@
         <p:spPr>
           <a:xfrm>
             <a:off x="777240" y="1673352"/>
-            <a:ext cx="10424160" cy="2468879"/>
+            <a:ext cx="10424160" cy="4572000"/>
           </a:xfrm>
           <a:prstGeom prst="rect">
             <a:avLst/>
@@ -18955,7 +19619,7 @@
               <a:spcAft>
                 <a:spcPts val="500"/>
               </a:spcAft>
-              <a:defRPr sz="1500" b="0">
+              <a:defRPr sz="1600" b="0">
                 <a:solidFill>
                   <a:srgbClr val="37474F"/>
                 </a:solidFill>
@@ -18974,7 +19638,7 @@
               <a:spcAft>
                 <a:spcPts val="500"/>
               </a:spcAft>
-              <a:defRPr sz="1500" b="0">
+              <a:defRPr sz="1600" b="0">
                 <a:solidFill>
                   <a:srgbClr val="37474F"/>
                 </a:solidFill>
@@ -18993,7 +19657,7 @@
               <a:spcAft>
                 <a:spcPts val="500"/>
               </a:spcAft>
-              <a:defRPr sz="1500" b="0">
+              <a:defRPr sz="1600" b="0">
                 <a:solidFill>
                   <a:srgbClr val="37474F"/>
                 </a:solidFill>
@@ -19012,7 +19676,7 @@
               <a:spcAft>
                 <a:spcPts val="500"/>
               </a:spcAft>
-              <a:defRPr sz="1500" b="0">
+              <a:defRPr sz="1600" b="0">
                 <a:solidFill>
                   <a:srgbClr val="37474F"/>
                 </a:solidFill>
@@ -19031,7 +19695,7 @@
               <a:spcAft>
                 <a:spcPts val="500"/>
               </a:spcAft>
-              <a:defRPr sz="1500" b="0">
+              <a:defRPr sz="1600" b="0">
                 <a:solidFill>
                   <a:srgbClr val="37474F"/>
                 </a:solidFill>
@@ -19050,7 +19714,7 @@
               <a:spcAft>
                 <a:spcPts val="500"/>
               </a:spcAft>
-              <a:defRPr sz="1500" b="0">
+              <a:defRPr sz="1600" b="0">
                 <a:solidFill>
                   <a:srgbClr val="37474F"/>
                 </a:solidFill>
@@ -19323,7 +19987,7 @@
           <a:lstStyle/>
           <a:p>
             <a:pPr algn="r">
-              <a:defRPr sz="1000" b="0">
+              <a:defRPr sz="1100" b="0">
                 <a:solidFill>
                   <a:srgbClr val="78909C"/>
                 </a:solidFill>
@@ -19359,7 +20023,7 @@
           <a:lstStyle/>
           <a:p>
             <a:pPr>
-              <a:defRPr sz="2400" b="1">
+              <a:defRPr sz="2600" b="1">
                 <a:solidFill>
                   <a:srgbClr val="0D2B45"/>
                 </a:solidFill>
@@ -19381,7 +20045,7 @@
         <p:spPr>
           <a:xfrm>
             <a:off x="502920" y="1554480"/>
-            <a:ext cx="11155680" cy="2651759"/>
+            <a:ext cx="11155680" cy="4800600"/>
           </a:xfrm>
           <a:prstGeom prst="roundRect">
             <a:avLst/>
@@ -19426,7 +20090,7 @@
         <p:spPr>
           <a:xfrm>
             <a:off x="777240" y="1673352"/>
-            <a:ext cx="10424160" cy="2468879"/>
+            <a:ext cx="10424160" cy="4572000"/>
           </a:xfrm>
           <a:prstGeom prst="rect">
             <a:avLst/>
@@ -19446,7 +20110,7 @@
               <a:spcAft>
                 <a:spcPts val="500"/>
               </a:spcAft>
-              <a:defRPr sz="1500" b="0">
+              <a:defRPr sz="1600" b="0">
                 <a:solidFill>
                   <a:srgbClr val="37474F"/>
                 </a:solidFill>
@@ -19465,7 +20129,7 @@
               <a:spcAft>
                 <a:spcPts val="500"/>
               </a:spcAft>
-              <a:defRPr sz="1500" b="0">
+              <a:defRPr sz="1600" b="0">
                 <a:solidFill>
                   <a:srgbClr val="37474F"/>
                 </a:solidFill>
@@ -19484,7 +20148,7 @@
               <a:spcAft>
                 <a:spcPts val="500"/>
               </a:spcAft>
-              <a:defRPr sz="1500" b="0">
+              <a:defRPr sz="1600" b="0">
                 <a:solidFill>
                   <a:srgbClr val="37474F"/>
                 </a:solidFill>
@@ -19503,7 +20167,7 @@
               <a:spcAft>
                 <a:spcPts val="500"/>
               </a:spcAft>
-              <a:defRPr sz="1500" b="0">
+              <a:defRPr sz="1600" b="0">
                 <a:solidFill>
                   <a:srgbClr val="37474F"/>
                 </a:solidFill>
@@ -19522,7 +20186,7 @@
               <a:spcAft>
                 <a:spcPts val="500"/>
               </a:spcAft>
-              <a:defRPr sz="1500" b="0">
+              <a:defRPr sz="1600" b="0">
                 <a:solidFill>
                   <a:srgbClr val="37474F"/>
                 </a:solidFill>
@@ -19541,7 +20205,7 @@
               <a:spcAft>
                 <a:spcPts val="500"/>
               </a:spcAft>
-              <a:defRPr sz="1500" b="0">
+              <a:defRPr sz="1600" b="0">
                 <a:solidFill>
                   <a:srgbClr val="37474F"/>
                 </a:solidFill>

</xml_diff>